<commit_message>
Presentación compatible con Canva (temporal)
Co-Authored-By: Claude Opus 5.5 <noreply@anthropic.com>
Claude-Session: https://claude.ai/code/session_01TBcxHju54x71a6Cyt7s4f5
</commit_message>
<xml_diff>
--- a/Vida_Submarina_SISEP.pptx
+++ b/Vida_Submarina_SISEP.pptx
@@ -4406,7 +4406,7 @@
                 <a:alpha val="80000"/>
               </a:srgbClr>
             </a:solidFill>
-            <a:prstDash val="sysDash"/>
+            <a:prstDash val="dash"/>
           </a:ln>
         </p:spPr>
       </p:sp>
@@ -4431,7 +4431,7 @@
                 <a:alpha val="80000"/>
               </a:srgbClr>
             </a:solidFill>
-            <a:prstDash val="sysDash"/>
+            <a:prstDash val="dash"/>
           </a:ln>
         </p:spPr>
       </p:sp>
@@ -14054,7 +14054,7 @@
               <a:srgbClr val="0E7C86"/>
             </a:solidFill>
             <a:prstDash val="dash"/>
-            <a:tailEnd type="open"/>
+            <a:tailEnd type="triangle"/>
           </a:ln>
         </p:spPr>
       </p:sp>
@@ -26145,7 +26145,7 @@
               <a:srgbClr val="5A6B7B"/>
             </a:solidFill>
             <a:prstDash val="dash"/>
-            <a:tailEnd type="open"/>
+            <a:tailEnd type="triangle"/>
           </a:ln>
         </p:spPr>
       </p:sp>
@@ -26405,7 +26405,7 @@
               <a:srgbClr val="5A6B7B"/>
             </a:solidFill>
             <a:prstDash val="dash"/>
-            <a:tailEnd type="open"/>
+            <a:tailEnd type="triangle"/>
           </a:ln>
         </p:spPr>
       </p:sp>
@@ -34829,7 +34829,6 @@
               </a:srgbClr>
             </a:solidFill>
             <a:prstDash val="solid"/>
-            <a:tailEnd type="oval"/>
           </a:ln>
         </p:spPr>
       </p:sp>
@@ -35070,7 +35069,6 @@
               </a:srgbClr>
             </a:solidFill>
             <a:prstDash val="solid"/>
-            <a:tailEnd type="oval"/>
           </a:ln>
         </p:spPr>
       </p:sp>
@@ -35311,7 +35309,6 @@
               </a:srgbClr>
             </a:solidFill>
             <a:prstDash val="solid"/>
-            <a:tailEnd type="oval"/>
           </a:ln>
         </p:spPr>
       </p:sp>

</xml_diff>

<commit_message>
Presentación optimizada para Canva (temporal)
Co-Authored-By: Claude Opus 5.5 <noreply@anthropic.com>
Claude-Session: https://claude.ai/code/session_01TBcxHju54x71a6Cyt7s4f5
</commit_message>
<xml_diff>
--- a/Vida_Submarina_SISEP.pptx
+++ b/Vida_Submarina_SISEP.pptx
@@ -11653,9 +11653,29 @@
           <p:nvPr/>
         </p:nvSpPr>
         <p:spPr>
+          <a:xfrm rot="7925771">
+            <a:off x="4696066" y="3465925"/>
+            <a:ext cx="120015" cy="120015"/>
+          </a:xfrm>
+          <a:prstGeom prst="triangle">
+            <a:avLst/>
+          </a:prstGeom>
+          <a:solidFill>
+            <a:srgbClr val="0F4C6B"/>
+          </a:solidFill>
+          <a:ln/>
+        </p:spPr>
+      </p:sp>
+      <p:sp>
+        <p:nvSpPr>
+          <p:cNvPr id="9" name="Shape 7"/>
+          <p:cNvSpPr/>
+          <p:nvPr/>
+        </p:nvSpPr>
+        <p:spPr>
           <a:xfrm>
             <a:off x="3474720" y="2368296"/>
-            <a:ext cx="1325880" cy="1197864"/>
+            <a:ext cx="1281353" cy="1157636"/>
           </a:xfrm>
           <a:prstGeom prst="line">
             <a:avLst/>
@@ -11666,20 +11686,39 @@
               <a:srgbClr val="0F4C6B"/>
             </a:solidFill>
             <a:prstDash val="solid"/>
-            <a:tailEnd type="triangle"/>
           </a:ln>
         </p:spPr>
       </p:sp>
       <p:sp>
         <p:nvSpPr>
-          <p:cNvPr id="9" name="Shape 7"/>
+          <p:cNvPr id="10" name="Shape 8"/>
+          <p:cNvSpPr/>
+          <p:nvPr/>
+        </p:nvSpPr>
+        <p:spPr>
+          <a:xfrm rot="6562680">
+            <a:off x="4683984" y="3760562"/>
+            <a:ext cx="120015" cy="120015"/>
+          </a:xfrm>
+          <a:prstGeom prst="triangle">
+            <a:avLst/>
+          </a:prstGeom>
+          <a:solidFill>
+            <a:srgbClr val="0F4C6B"/>
+          </a:solidFill>
+          <a:ln/>
+        </p:spPr>
+      </p:sp>
+      <p:sp>
+        <p:nvSpPr>
+          <p:cNvPr id="11" name="Shape 9"/>
           <p:cNvSpPr/>
           <p:nvPr/>
         </p:nvSpPr>
         <p:spPr>
           <a:xfrm>
             <a:off x="3474720" y="3374136"/>
-            <a:ext cx="1325880" cy="466344"/>
+            <a:ext cx="1269272" cy="446434"/>
           </a:xfrm>
           <a:prstGeom prst="line">
             <a:avLst/>
@@ -11690,20 +11729,39 @@
               <a:srgbClr val="0F4C6B"/>
             </a:solidFill>
             <a:prstDash val="solid"/>
-            <a:tailEnd type="triangle"/>
           </a:ln>
         </p:spPr>
       </p:sp>
       <p:sp>
         <p:nvSpPr>
-          <p:cNvPr id="10" name="Shape 8"/>
+          <p:cNvPr id="12" name="Shape 10"/>
+          <p:cNvSpPr/>
+          <p:nvPr/>
+        </p:nvSpPr>
+        <p:spPr>
+          <a:xfrm rot="4721404">
+            <a:off x="4681750" y="4066561"/>
+            <a:ext cx="120015" cy="120015"/>
+          </a:xfrm>
+          <a:prstGeom prst="triangle">
+            <a:avLst/>
+          </a:prstGeom>
+          <a:solidFill>
+            <a:srgbClr val="0F4C6B"/>
+          </a:solidFill>
+          <a:ln/>
+        </p:spPr>
+      </p:sp>
+      <p:sp>
+        <p:nvSpPr>
+          <p:cNvPr id="13" name="Shape 11"/>
           <p:cNvSpPr/>
           <p:nvPr/>
         </p:nvSpPr>
         <p:spPr>
           <a:xfrm flipV="1">
-            <a:off x="3474720" y="4114800"/>
-            <a:ext cx="1325880" cy="265176"/>
+            <a:off x="3474720" y="4126568"/>
+            <a:ext cx="1267038" cy="253408"/>
           </a:xfrm>
           <a:prstGeom prst="line">
             <a:avLst/>
@@ -11714,20 +11772,39 @@
               <a:srgbClr val="0F4C6B"/>
             </a:solidFill>
             <a:prstDash val="solid"/>
-            <a:tailEnd type="triangle"/>
           </a:ln>
         </p:spPr>
       </p:sp>
       <p:sp>
         <p:nvSpPr>
-          <p:cNvPr id="11" name="Shape 9"/>
+          <p:cNvPr id="14" name="Shape 12"/>
+          <p:cNvSpPr/>
+          <p:nvPr/>
+        </p:nvSpPr>
+        <p:spPr>
+          <a:xfrm rot="3184016">
+            <a:off x="4692626" y="4365170"/>
+            <a:ext cx="120015" cy="120015"/>
+          </a:xfrm>
+          <a:prstGeom prst="triangle">
+            <a:avLst/>
+          </a:prstGeom>
+          <a:solidFill>
+            <a:srgbClr val="0F4C6B"/>
+          </a:solidFill>
+          <a:ln/>
+        </p:spPr>
+      </p:sp>
+      <p:sp>
+        <p:nvSpPr>
+          <p:cNvPr id="15" name="Shape 13"/>
           <p:cNvSpPr/>
           <p:nvPr/>
         </p:nvSpPr>
         <p:spPr>
           <a:xfrm flipV="1">
-            <a:off x="3474720" y="4389120"/>
-            <a:ext cx="1325880" cy="996696"/>
+            <a:off x="3474720" y="4425177"/>
+            <a:ext cx="1277914" cy="960639"/>
           </a:xfrm>
           <a:prstGeom prst="line">
             <a:avLst/>
@@ -11738,20 +11815,39 @@
               <a:srgbClr val="0F4C6B"/>
             </a:solidFill>
             <a:prstDash val="solid"/>
-            <a:tailEnd type="triangle"/>
           </a:ln>
         </p:spPr>
       </p:sp>
       <p:sp>
         <p:nvSpPr>
-          <p:cNvPr id="12" name="Shape 10"/>
+          <p:cNvPr id="16" name="Shape 14"/>
+          <p:cNvSpPr/>
+          <p:nvPr/>
+        </p:nvSpPr>
+        <p:spPr>
+          <a:xfrm rot="14133661">
+            <a:off x="7396122" y="3563657"/>
+            <a:ext cx="120015" cy="120015"/>
+          </a:xfrm>
+          <a:prstGeom prst="triangle">
+            <a:avLst/>
+          </a:prstGeom>
+          <a:solidFill>
+            <a:srgbClr val="0F4C6B"/>
+          </a:solidFill>
+          <a:ln/>
+        </p:spPr>
+      </p:sp>
+      <p:sp>
+        <p:nvSpPr>
+          <p:cNvPr id="17" name="Shape 15"/>
           <p:cNvSpPr/>
           <p:nvPr/>
         </p:nvSpPr>
         <p:spPr>
           <a:xfrm flipH="1">
-            <a:off x="7406640" y="2779776"/>
-            <a:ext cx="1280160" cy="877824"/>
+            <a:off x="7456130" y="2779776"/>
+            <a:ext cx="1230670" cy="843888"/>
           </a:xfrm>
           <a:prstGeom prst="line">
             <a:avLst/>
@@ -11762,20 +11858,39 @@
               <a:srgbClr val="0F4C6B"/>
             </a:solidFill>
             <a:prstDash val="solid"/>
-            <a:tailEnd type="triangle"/>
           </a:ln>
         </p:spPr>
       </p:sp>
       <p:sp>
         <p:nvSpPr>
-          <p:cNvPr id="13" name="Shape 11"/>
+          <p:cNvPr id="18" name="Shape 16"/>
+          <p:cNvSpPr/>
+          <p:nvPr/>
+        </p:nvSpPr>
+        <p:spPr>
+          <a:xfrm rot="16175445">
+            <a:off x="7406638" y="3917204"/>
+            <a:ext cx="120015" cy="120015"/>
+          </a:xfrm>
+          <a:prstGeom prst="triangle">
+            <a:avLst/>
+          </a:prstGeom>
+          <a:solidFill>
+            <a:srgbClr val="0F4C6B"/>
+          </a:solidFill>
+          <a:ln/>
+        </p:spPr>
+      </p:sp>
+      <p:sp>
+        <p:nvSpPr>
+          <p:cNvPr id="19" name="Shape 17"/>
           <p:cNvSpPr/>
           <p:nvPr/>
         </p:nvSpPr>
         <p:spPr>
           <a:xfrm flipH="1">
-            <a:off x="7406640" y="3968496"/>
-            <a:ext cx="1280160" cy="9144"/>
+            <a:off x="7466646" y="3968496"/>
+            <a:ext cx="1220154" cy="8715"/>
           </a:xfrm>
           <a:prstGeom prst="line">
             <a:avLst/>
@@ -11786,20 +11901,39 @@
               <a:srgbClr val="0F4C6B"/>
             </a:solidFill>
             <a:prstDash val="solid"/>
-            <a:tailEnd type="triangle"/>
           </a:ln>
         </p:spPr>
       </p:sp>
       <p:sp>
         <p:nvSpPr>
-          <p:cNvPr id="14" name="Shape 12"/>
+          <p:cNvPr id="20" name="Shape 18"/>
+          <p:cNvSpPr/>
+          <p:nvPr/>
+        </p:nvSpPr>
+        <p:spPr>
+          <a:xfrm rot="-3367288">
+            <a:off x="7396452" y="4271123"/>
+            <a:ext cx="120015" cy="120015"/>
+          </a:xfrm>
+          <a:prstGeom prst="triangle">
+            <a:avLst/>
+          </a:prstGeom>
+          <a:solidFill>
+            <a:srgbClr val="0F4C6B"/>
+          </a:solidFill>
+          <a:ln/>
+        </p:spPr>
+      </p:sp>
+      <p:sp>
+        <p:nvSpPr>
+          <p:cNvPr id="21" name="Shape 19"/>
           <p:cNvSpPr/>
           <p:nvPr/>
         </p:nvSpPr>
         <p:spPr>
           <a:xfrm flipH="1" flipV="1">
-            <a:off x="7406640" y="4297680"/>
-            <a:ext cx="1280160" cy="859536"/>
+            <a:off x="7456459" y="4331130"/>
+            <a:ext cx="1230341" cy="826086"/>
           </a:xfrm>
           <a:prstGeom prst="line">
             <a:avLst/>
@@ -11810,13 +11944,12 @@
               <a:srgbClr val="0F4C6B"/>
             </a:solidFill>
             <a:prstDash val="solid"/>
-            <a:tailEnd type="triangle"/>
           </a:ln>
         </p:spPr>
       </p:sp>
       <p:sp>
         <p:nvSpPr>
-          <p:cNvPr id="15" name="Shape 13"/>
+          <p:cNvPr id="22" name="Shape 20"/>
           <p:cNvSpPr/>
           <p:nvPr/>
         </p:nvSpPr>
@@ -11850,7 +11983,7 @@
       </p:sp>
       <p:sp>
         <p:nvSpPr>
-          <p:cNvPr id="16" name="Shape 14"/>
+          <p:cNvPr id="23" name="Shape 21"/>
           <p:cNvSpPr/>
           <p:nvPr/>
         </p:nvSpPr>
@@ -11870,7 +12003,7 @@
       </p:sp>
       <p:pic>
         <p:nvPicPr>
-          <p:cNvPr id="17" name="Image 0" descr="preencoded.png">    </p:cNvPr>
+          <p:cNvPr id="24" name="Image 0" descr="preencoded.png">    </p:cNvPr>
           <p:cNvPicPr>
             <a:picLocks noChangeAspect="1"/>
           </p:cNvPicPr>
@@ -11894,7 +12027,7 @@
       </p:pic>
       <p:sp>
         <p:nvSpPr>
-          <p:cNvPr id="18" name="Text 15"/>
+          <p:cNvPr id="25" name="Text 22"/>
           <p:cNvSpPr txBox="1"/>
           <p:nvPr/>
         </p:nvSpPr>
@@ -11933,7 +12066,7 @@
       </p:sp>
       <p:sp>
         <p:nvSpPr>
-          <p:cNvPr id="19" name="Text 16"/>
+          <p:cNvPr id="26" name="Text 23"/>
           <p:cNvSpPr txBox="1"/>
           <p:nvPr/>
         </p:nvSpPr>
@@ -11972,7 +12105,7 @@
       </p:sp>
       <p:sp>
         <p:nvSpPr>
-          <p:cNvPr id="20" name="Shape 17"/>
+          <p:cNvPr id="27" name="Shape 24"/>
           <p:cNvSpPr/>
           <p:nvPr/>
         </p:nvSpPr>
@@ -12006,7 +12139,7 @@
       </p:sp>
       <p:sp>
         <p:nvSpPr>
-          <p:cNvPr id="21" name="Shape 18"/>
+          <p:cNvPr id="28" name="Shape 25"/>
           <p:cNvSpPr/>
           <p:nvPr/>
         </p:nvSpPr>
@@ -12026,7 +12159,7 @@
       </p:sp>
       <p:pic>
         <p:nvPicPr>
-          <p:cNvPr id="22" name="Image 1" descr="preencoded.png">    </p:cNvPr>
+          <p:cNvPr id="29" name="Image 1" descr="preencoded.png">    </p:cNvPr>
           <p:cNvPicPr>
             <a:picLocks noChangeAspect="1"/>
           </p:cNvPicPr>
@@ -12050,7 +12183,7 @@
       </p:pic>
       <p:sp>
         <p:nvSpPr>
-          <p:cNvPr id="23" name="Text 19"/>
+          <p:cNvPr id="30" name="Text 26"/>
           <p:cNvSpPr txBox="1"/>
           <p:nvPr/>
         </p:nvSpPr>
@@ -12089,7 +12222,7 @@
       </p:sp>
       <p:sp>
         <p:nvSpPr>
-          <p:cNvPr id="24" name="Text 20"/>
+          <p:cNvPr id="31" name="Text 27"/>
           <p:cNvSpPr txBox="1"/>
           <p:nvPr/>
         </p:nvSpPr>
@@ -12128,7 +12261,7 @@
       </p:sp>
       <p:sp>
         <p:nvSpPr>
-          <p:cNvPr id="25" name="Shape 21"/>
+          <p:cNvPr id="32" name="Shape 28"/>
           <p:cNvSpPr/>
           <p:nvPr/>
         </p:nvSpPr>
@@ -12162,7 +12295,7 @@
       </p:sp>
       <p:sp>
         <p:nvSpPr>
-          <p:cNvPr id="26" name="Shape 22"/>
+          <p:cNvPr id="33" name="Shape 29"/>
           <p:cNvSpPr/>
           <p:nvPr/>
         </p:nvSpPr>
@@ -12182,7 +12315,7 @@
       </p:sp>
       <p:pic>
         <p:nvPicPr>
-          <p:cNvPr id="27" name="Image 2" descr="preencoded.png">    </p:cNvPr>
+          <p:cNvPr id="34" name="Image 2" descr="preencoded.png">    </p:cNvPr>
           <p:cNvPicPr>
             <a:picLocks noChangeAspect="1"/>
           </p:cNvPicPr>
@@ -12206,7 +12339,7 @@
       </p:pic>
       <p:sp>
         <p:nvSpPr>
-          <p:cNvPr id="28" name="Text 23"/>
+          <p:cNvPr id="35" name="Text 30"/>
           <p:cNvSpPr txBox="1"/>
           <p:nvPr/>
         </p:nvSpPr>
@@ -12245,7 +12378,7 @@
       </p:sp>
       <p:sp>
         <p:nvSpPr>
-          <p:cNvPr id="29" name="Text 24"/>
+          <p:cNvPr id="36" name="Text 31"/>
           <p:cNvSpPr txBox="1"/>
           <p:nvPr/>
         </p:nvSpPr>
@@ -12284,7 +12417,7 @@
       </p:sp>
       <p:sp>
         <p:nvSpPr>
-          <p:cNvPr id="30" name="Shape 25"/>
+          <p:cNvPr id="37" name="Shape 32"/>
           <p:cNvSpPr/>
           <p:nvPr/>
         </p:nvSpPr>
@@ -12318,7 +12451,7 @@
       </p:sp>
       <p:sp>
         <p:nvSpPr>
-          <p:cNvPr id="31" name="Shape 26"/>
+          <p:cNvPr id="38" name="Shape 33"/>
           <p:cNvSpPr/>
           <p:nvPr/>
         </p:nvSpPr>
@@ -12338,7 +12471,7 @@
       </p:sp>
       <p:pic>
         <p:nvPicPr>
-          <p:cNvPr id="32" name="Image 3" descr="preencoded.png">    </p:cNvPr>
+          <p:cNvPr id="39" name="Image 3" descr="preencoded.png">    </p:cNvPr>
           <p:cNvPicPr>
             <a:picLocks noChangeAspect="1"/>
           </p:cNvPicPr>
@@ -12362,7 +12495,7 @@
       </p:pic>
       <p:sp>
         <p:nvSpPr>
-          <p:cNvPr id="33" name="Text 27"/>
+          <p:cNvPr id="40" name="Text 34"/>
           <p:cNvSpPr txBox="1"/>
           <p:nvPr/>
         </p:nvSpPr>
@@ -12401,7 +12534,7 @@
       </p:sp>
       <p:sp>
         <p:nvSpPr>
-          <p:cNvPr id="34" name="Text 28"/>
+          <p:cNvPr id="41" name="Text 35"/>
           <p:cNvSpPr txBox="1"/>
           <p:nvPr/>
         </p:nvSpPr>
@@ -12440,7 +12573,7 @@
       </p:sp>
       <p:sp>
         <p:nvSpPr>
-          <p:cNvPr id="35" name="Shape 29"/>
+          <p:cNvPr id="42" name="Shape 36"/>
           <p:cNvSpPr/>
           <p:nvPr/>
         </p:nvSpPr>
@@ -12474,7 +12607,7 @@
       </p:sp>
       <p:sp>
         <p:nvSpPr>
-          <p:cNvPr id="36" name="Shape 30"/>
+          <p:cNvPr id="43" name="Shape 37"/>
           <p:cNvSpPr/>
           <p:nvPr/>
         </p:nvSpPr>
@@ -12494,7 +12627,7 @@
       </p:sp>
       <p:pic>
         <p:nvPicPr>
-          <p:cNvPr id="37" name="Image 4" descr="preencoded.png">    </p:cNvPr>
+          <p:cNvPr id="44" name="Image 4" descr="preencoded.png">    </p:cNvPr>
           <p:cNvPicPr>
             <a:picLocks noChangeAspect="1"/>
           </p:cNvPicPr>
@@ -12518,7 +12651,7 @@
       </p:pic>
       <p:sp>
         <p:nvSpPr>
-          <p:cNvPr id="38" name="Text 31"/>
+          <p:cNvPr id="45" name="Text 38"/>
           <p:cNvSpPr txBox="1"/>
           <p:nvPr/>
         </p:nvSpPr>
@@ -12557,7 +12690,7 @@
       </p:sp>
       <p:sp>
         <p:nvSpPr>
-          <p:cNvPr id="39" name="Text 32"/>
+          <p:cNvPr id="46" name="Text 39"/>
           <p:cNvSpPr txBox="1"/>
           <p:nvPr/>
         </p:nvSpPr>
@@ -12596,7 +12729,7 @@
       </p:sp>
       <p:sp>
         <p:nvSpPr>
-          <p:cNvPr id="40" name="Shape 33"/>
+          <p:cNvPr id="47" name="Shape 40"/>
           <p:cNvSpPr/>
           <p:nvPr/>
         </p:nvSpPr>
@@ -12630,7 +12763,7 @@
       </p:sp>
       <p:sp>
         <p:nvSpPr>
-          <p:cNvPr id="41" name="Shape 34"/>
+          <p:cNvPr id="48" name="Shape 41"/>
           <p:cNvSpPr/>
           <p:nvPr/>
         </p:nvSpPr>
@@ -12650,7 +12783,7 @@
       </p:sp>
       <p:pic>
         <p:nvPicPr>
-          <p:cNvPr id="42" name="Image 5" descr="preencoded.png">    </p:cNvPr>
+          <p:cNvPr id="49" name="Image 5" descr="preencoded.png">    </p:cNvPr>
           <p:cNvPicPr>
             <a:picLocks noChangeAspect="1"/>
           </p:cNvPicPr>
@@ -12674,7 +12807,7 @@
       </p:pic>
       <p:sp>
         <p:nvSpPr>
-          <p:cNvPr id="43" name="Text 35"/>
+          <p:cNvPr id="50" name="Text 42"/>
           <p:cNvSpPr txBox="1"/>
           <p:nvPr/>
         </p:nvSpPr>
@@ -12713,7 +12846,7 @@
       </p:sp>
       <p:sp>
         <p:nvSpPr>
-          <p:cNvPr id="44" name="Text 36"/>
+          <p:cNvPr id="51" name="Text 43"/>
           <p:cNvSpPr txBox="1"/>
           <p:nvPr/>
         </p:nvSpPr>
@@ -12752,7 +12885,7 @@
       </p:sp>
       <p:sp>
         <p:nvSpPr>
-          <p:cNvPr id="45" name="Shape 37"/>
+          <p:cNvPr id="52" name="Shape 44"/>
           <p:cNvSpPr/>
           <p:nvPr/>
         </p:nvSpPr>
@@ -12786,7 +12919,7 @@
       </p:sp>
       <p:sp>
         <p:nvSpPr>
-          <p:cNvPr id="46" name="Shape 38"/>
+          <p:cNvPr id="53" name="Shape 45"/>
           <p:cNvSpPr/>
           <p:nvPr/>
         </p:nvSpPr>
@@ -12806,7 +12939,7 @@
       </p:sp>
       <p:pic>
         <p:nvPicPr>
-          <p:cNvPr id="47" name="Image 6" descr="preencoded.png">    </p:cNvPr>
+          <p:cNvPr id="54" name="Image 6" descr="preencoded.png">    </p:cNvPr>
           <p:cNvPicPr>
             <a:picLocks noChangeAspect="1"/>
           </p:cNvPicPr>
@@ -12830,7 +12963,7 @@
       </p:pic>
       <p:sp>
         <p:nvSpPr>
-          <p:cNvPr id="48" name="Text 39"/>
+          <p:cNvPr id="55" name="Text 46"/>
           <p:cNvSpPr txBox="1"/>
           <p:nvPr/>
         </p:nvSpPr>
@@ -12869,7 +13002,7 @@
       </p:sp>
       <p:sp>
         <p:nvSpPr>
-          <p:cNvPr id="49" name="Text 40"/>
+          <p:cNvPr id="56" name="Text 47"/>
           <p:cNvSpPr txBox="1"/>
           <p:nvPr/>
         </p:nvSpPr>
@@ -12908,7 +13041,7 @@
       </p:sp>
       <p:sp>
         <p:nvSpPr>
-          <p:cNvPr id="50" name="Shape 41"/>
+          <p:cNvPr id="57" name="Shape 48"/>
           <p:cNvSpPr/>
           <p:nvPr/>
         </p:nvSpPr>
@@ -12937,14 +13070,34 @@
       </p:sp>
       <p:sp>
         <p:nvSpPr>
-          <p:cNvPr id="51" name="Shape 42"/>
+          <p:cNvPr id="58" name="Shape 49"/>
+          <p:cNvSpPr/>
+          <p:nvPr/>
+        </p:nvSpPr>
+        <p:spPr>
+          <a:xfrm rot="5400000">
+            <a:off x="931545" y="5929313"/>
+            <a:ext cx="120015" cy="120015"/>
+          </a:xfrm>
+          <a:prstGeom prst="triangle">
+            <a:avLst/>
+          </a:prstGeom>
+          <a:solidFill>
+            <a:srgbClr val="0F4C6B"/>
+          </a:solidFill>
+          <a:ln/>
+        </p:spPr>
+      </p:sp>
+      <p:sp>
+        <p:nvSpPr>
+          <p:cNvPr id="59" name="Shape 50"/>
           <p:cNvSpPr/>
           <p:nvPr/>
         </p:nvSpPr>
         <p:spPr>
           <a:xfrm>
             <a:off x="548640" y="5989320"/>
-            <a:ext cx="502920" cy="0"/>
+            <a:ext cx="442912" cy="0"/>
           </a:xfrm>
           <a:prstGeom prst="line">
             <a:avLst/>
@@ -12955,13 +13108,12 @@
               <a:srgbClr val="0F4C6B"/>
             </a:solidFill>
             <a:prstDash val="solid"/>
-            <a:tailEnd type="triangle"/>
           </a:ln>
         </p:spPr>
       </p:sp>
       <p:sp>
         <p:nvSpPr>
-          <p:cNvPr id="52" name="Text 43"/>
+          <p:cNvPr id="60" name="Text 51"/>
           <p:cNvSpPr txBox="1"/>
           <p:nvPr/>
         </p:nvSpPr>
@@ -13000,7 +13152,7 @@
       </p:sp>
       <p:sp>
         <p:nvSpPr>
-          <p:cNvPr id="53" name="Text 44"/>
+          <p:cNvPr id="61" name="Text 52"/>
           <p:cNvSpPr txBox="1"/>
           <p:nvPr/>
         </p:nvSpPr>
@@ -13039,7 +13191,7 @@
       </p:sp>
       <p:sp>
         <p:nvSpPr>
-          <p:cNvPr id="54" name="Text 45"/>
+          <p:cNvPr id="62" name="Text 53"/>
           <p:cNvSpPr txBox="1"/>
           <p:nvPr/>
         </p:nvSpPr>
@@ -13078,7 +13230,7 @@
       </p:sp>
       <p:sp>
         <p:nvSpPr>
-          <p:cNvPr id="55" name="Text 46"/>
+          <p:cNvPr id="63" name="Text 54"/>
           <p:cNvSpPr txBox="1"/>
           <p:nvPr/>
         </p:nvSpPr>
@@ -13117,7 +13269,7 @@
       </p:sp>
       <p:sp>
         <p:nvSpPr>
-          <p:cNvPr id="56" name="Text 47"/>
+          <p:cNvPr id="64" name="Text 55"/>
           <p:cNvSpPr txBox="1"/>
           <p:nvPr/>
         </p:nvSpPr>
@@ -14041,9 +14193,29 @@
           <p:nvPr/>
         </p:nvSpPr>
         <p:spPr>
+          <a:xfrm rot="10800000">
+            <a:off x="7915275" y="5132070"/>
+            <a:ext cx="125730" cy="125730"/>
+          </a:xfrm>
+          <a:prstGeom prst="triangle">
+            <a:avLst/>
+          </a:prstGeom>
+          <a:solidFill>
+            <a:srgbClr val="0E7C86"/>
+          </a:solidFill>
+          <a:ln/>
+        </p:spPr>
+      </p:sp>
+      <p:sp>
+        <p:nvSpPr>
+          <p:cNvPr id="29" name="Shape 27"/>
+          <p:cNvSpPr/>
+          <p:nvPr/>
+        </p:nvSpPr>
+        <p:spPr>
           <a:xfrm>
             <a:off x="7978140" y="4617720"/>
-            <a:ext cx="0" cy="640080"/>
+            <a:ext cx="0" cy="577215"/>
           </a:xfrm>
           <a:prstGeom prst="line">
             <a:avLst/>
@@ -14054,13 +14226,12 @@
               <a:srgbClr val="0E7C86"/>
             </a:solidFill>
             <a:prstDash val="dash"/>
-            <a:tailEnd type="triangle"/>
           </a:ln>
         </p:spPr>
       </p:sp>
       <p:sp>
         <p:nvSpPr>
-          <p:cNvPr id="29" name="Text 27"/>
+          <p:cNvPr id="30" name="Text 28"/>
           <p:cNvSpPr txBox="1"/>
           <p:nvPr/>
         </p:nvSpPr>
@@ -14099,7 +14270,7 @@
       </p:sp>
       <p:sp>
         <p:nvSpPr>
-          <p:cNvPr id="30" name="Shape 28"/>
+          <p:cNvPr id="31" name="Shape 29"/>
           <p:cNvSpPr/>
           <p:nvPr/>
         </p:nvSpPr>
@@ -14124,7 +14295,7 @@
       </p:sp>
       <p:sp>
         <p:nvSpPr>
-          <p:cNvPr id="31" name="Shape 29"/>
+          <p:cNvPr id="32" name="Shape 30"/>
           <p:cNvSpPr/>
           <p:nvPr/>
         </p:nvSpPr>
@@ -14147,7 +14318,7 @@
       </p:sp>
       <p:sp>
         <p:nvSpPr>
-          <p:cNvPr id="32" name="Shape 30"/>
+          <p:cNvPr id="33" name="Shape 31"/>
           <p:cNvSpPr/>
           <p:nvPr/>
         </p:nvSpPr>
@@ -14170,7 +14341,7 @@
       </p:sp>
       <p:sp>
         <p:nvSpPr>
-          <p:cNvPr id="33" name="Shape 31"/>
+          <p:cNvPr id="34" name="Shape 32"/>
           <p:cNvSpPr/>
           <p:nvPr/>
         </p:nvSpPr>
@@ -14193,7 +14364,7 @@
       </p:sp>
       <p:sp>
         <p:nvSpPr>
-          <p:cNvPr id="34" name="Shape 32"/>
+          <p:cNvPr id="35" name="Shape 33"/>
           <p:cNvSpPr/>
           <p:nvPr/>
         </p:nvSpPr>
@@ -14216,7 +14387,7 @@
       </p:sp>
       <p:sp>
         <p:nvSpPr>
-          <p:cNvPr id="35" name="Text 33"/>
+          <p:cNvPr id="36" name="Text 34"/>
           <p:cNvSpPr txBox="1"/>
           <p:nvPr/>
         </p:nvSpPr>
@@ -14255,7 +14426,7 @@
       </p:sp>
       <p:sp>
         <p:nvSpPr>
-          <p:cNvPr id="36" name="Text 34"/>
+          <p:cNvPr id="37" name="Text 35"/>
           <p:cNvSpPr txBox="1"/>
           <p:nvPr/>
         </p:nvSpPr>
@@ -14294,7 +14465,7 @@
       </p:sp>
       <p:sp>
         <p:nvSpPr>
-          <p:cNvPr id="37" name="Shape 35"/>
+          <p:cNvPr id="38" name="Shape 36"/>
           <p:cNvSpPr/>
           <p:nvPr/>
         </p:nvSpPr>
@@ -14319,7 +14490,7 @@
       </p:sp>
       <p:sp>
         <p:nvSpPr>
-          <p:cNvPr id="38" name="Shape 36"/>
+          <p:cNvPr id="39" name="Shape 37"/>
           <p:cNvSpPr/>
           <p:nvPr/>
         </p:nvSpPr>
@@ -14342,7 +14513,7 @@
       </p:sp>
       <p:sp>
         <p:nvSpPr>
-          <p:cNvPr id="39" name="Shape 37"/>
+          <p:cNvPr id="40" name="Shape 38"/>
           <p:cNvSpPr/>
           <p:nvPr/>
         </p:nvSpPr>
@@ -14365,7 +14536,7 @@
       </p:sp>
       <p:sp>
         <p:nvSpPr>
-          <p:cNvPr id="40" name="Shape 38"/>
+          <p:cNvPr id="41" name="Shape 39"/>
           <p:cNvSpPr/>
           <p:nvPr/>
         </p:nvSpPr>
@@ -14388,7 +14559,7 @@
       </p:sp>
       <p:sp>
         <p:nvSpPr>
-          <p:cNvPr id="41" name="Shape 39"/>
+          <p:cNvPr id="42" name="Shape 40"/>
           <p:cNvSpPr/>
           <p:nvPr/>
         </p:nvSpPr>
@@ -14411,7 +14582,7 @@
       </p:sp>
       <p:sp>
         <p:nvSpPr>
-          <p:cNvPr id="42" name="Text 40"/>
+          <p:cNvPr id="43" name="Text 41"/>
           <p:cNvSpPr txBox="1"/>
           <p:nvPr/>
         </p:nvSpPr>
@@ -14450,7 +14621,7 @@
       </p:sp>
       <p:sp>
         <p:nvSpPr>
-          <p:cNvPr id="43" name="Text 41"/>
+          <p:cNvPr id="44" name="Text 42"/>
           <p:cNvSpPr txBox="1"/>
           <p:nvPr/>
         </p:nvSpPr>
@@ -14489,7 +14660,7 @@
       </p:sp>
       <p:sp>
         <p:nvSpPr>
-          <p:cNvPr id="44" name="Text 42"/>
+          <p:cNvPr id="45" name="Text 43"/>
           <p:cNvSpPr txBox="1"/>
           <p:nvPr/>
         </p:nvSpPr>
@@ -14528,7 +14699,7 @@
       </p:sp>
       <p:sp>
         <p:nvSpPr>
-          <p:cNvPr id="45" name="Text 43"/>
+          <p:cNvPr id="46" name="Text 44"/>
           <p:cNvSpPr txBox="1"/>
           <p:nvPr/>
         </p:nvSpPr>
@@ -14809,9 +14980,29 @@
           <p:nvPr/>
         </p:nvSpPr>
         <p:spPr>
+          <a:xfrm rot="5400000">
+            <a:off x="1108710" y="2451735"/>
+            <a:ext cx="125730" cy="125730"/>
+          </a:xfrm>
+          <a:prstGeom prst="triangle">
+            <a:avLst/>
+          </a:prstGeom>
+          <a:solidFill>
+            <a:srgbClr val="0F4C6B"/>
+          </a:solidFill>
+          <a:ln/>
+        </p:spPr>
+      </p:sp>
+      <p:sp>
+        <p:nvSpPr>
+          <p:cNvPr id="9" name="Shape 7"/>
+          <p:cNvSpPr/>
+          <p:nvPr/>
+        </p:nvSpPr>
+        <p:spPr>
           <a:xfrm>
             <a:off x="914400" y="2514600"/>
-            <a:ext cx="320040" cy="0"/>
+            <a:ext cx="257175" cy="0"/>
           </a:xfrm>
           <a:prstGeom prst="line">
             <a:avLst/>
@@ -14822,13 +15013,12 @@
               <a:srgbClr val="0F4C6B"/>
             </a:solidFill>
             <a:prstDash val="solid"/>
-            <a:tailEnd type="triangle"/>
           </a:ln>
         </p:spPr>
       </p:sp>
       <p:sp>
         <p:nvSpPr>
-          <p:cNvPr id="9" name="Shape 7"/>
+          <p:cNvPr id="10" name="Shape 8"/>
           <p:cNvSpPr/>
           <p:nvPr/>
         </p:nvSpPr>
@@ -14862,7 +15052,7 @@
       </p:sp>
       <p:sp>
         <p:nvSpPr>
-          <p:cNvPr id="10" name="Text 8"/>
+          <p:cNvPr id="11" name="Text 9"/>
           <p:cNvSpPr txBox="1"/>
           <p:nvPr/>
         </p:nvSpPr>
@@ -14901,7 +15091,7 @@
       </p:sp>
       <p:sp>
         <p:nvSpPr>
-          <p:cNvPr id="11" name="Shape 9"/>
+          <p:cNvPr id="12" name="Shape 10"/>
           <p:cNvSpPr/>
           <p:nvPr/>
         </p:nvSpPr>
@@ -14921,7 +15111,7 @@
       </p:sp>
       <p:sp>
         <p:nvSpPr>
-          <p:cNvPr id="12" name="Text 10"/>
+          <p:cNvPr id="13" name="Text 11"/>
           <p:cNvSpPr txBox="1"/>
           <p:nvPr/>
         </p:nvSpPr>
@@ -14960,14 +15150,34 @@
       </p:sp>
       <p:sp>
         <p:nvSpPr>
-          <p:cNvPr id="13" name="Shape 11"/>
+          <p:cNvPr id="14" name="Shape 12"/>
+          <p:cNvSpPr/>
+          <p:nvPr/>
+        </p:nvSpPr>
+        <p:spPr>
+          <a:xfrm rot="5400000">
+            <a:off x="3714750" y="2451735"/>
+            <a:ext cx="125730" cy="125730"/>
+          </a:xfrm>
+          <a:prstGeom prst="triangle">
+            <a:avLst/>
+          </a:prstGeom>
+          <a:solidFill>
+            <a:srgbClr val="0F4C6B"/>
+          </a:solidFill>
+          <a:ln/>
+        </p:spPr>
+      </p:sp>
+      <p:sp>
+        <p:nvSpPr>
+          <p:cNvPr id="15" name="Shape 13"/>
           <p:cNvSpPr/>
           <p:nvPr/>
         </p:nvSpPr>
         <p:spPr>
           <a:xfrm>
             <a:off x="3520440" y="2514600"/>
-            <a:ext cx="320040" cy="0"/>
+            <a:ext cx="257175" cy="0"/>
           </a:xfrm>
           <a:prstGeom prst="line">
             <a:avLst/>
@@ -14978,13 +15188,12 @@
               <a:srgbClr val="0F4C6B"/>
             </a:solidFill>
             <a:prstDash val="solid"/>
-            <a:tailEnd type="triangle"/>
           </a:ln>
         </p:spPr>
       </p:sp>
       <p:sp>
         <p:nvSpPr>
-          <p:cNvPr id="14" name="Shape 12"/>
+          <p:cNvPr id="16" name="Shape 14"/>
           <p:cNvSpPr/>
           <p:nvPr/>
         </p:nvSpPr>
@@ -15018,7 +15227,7 @@
       </p:sp>
       <p:sp>
         <p:nvSpPr>
-          <p:cNvPr id="15" name="Text 13"/>
+          <p:cNvPr id="17" name="Text 15"/>
           <p:cNvSpPr txBox="1"/>
           <p:nvPr/>
         </p:nvSpPr>
@@ -15057,7 +15266,7 @@
       </p:sp>
       <p:sp>
         <p:nvSpPr>
-          <p:cNvPr id="16" name="Shape 14"/>
+          <p:cNvPr id="18" name="Shape 16"/>
           <p:cNvSpPr/>
           <p:nvPr/>
         </p:nvSpPr>
@@ -15077,7 +15286,7 @@
       </p:sp>
       <p:sp>
         <p:nvSpPr>
-          <p:cNvPr id="17" name="Text 15"/>
+          <p:cNvPr id="19" name="Text 17"/>
           <p:cNvSpPr txBox="1"/>
           <p:nvPr/>
         </p:nvSpPr>
@@ -15116,14 +15325,34 @@
       </p:sp>
       <p:sp>
         <p:nvSpPr>
-          <p:cNvPr id="18" name="Shape 16"/>
+          <p:cNvPr id="20" name="Shape 18"/>
+          <p:cNvSpPr/>
+          <p:nvPr/>
+        </p:nvSpPr>
+        <p:spPr>
+          <a:xfrm rot="5400000">
+            <a:off x="6320790" y="2451735"/>
+            <a:ext cx="125730" cy="125730"/>
+          </a:xfrm>
+          <a:prstGeom prst="triangle">
+            <a:avLst/>
+          </a:prstGeom>
+          <a:solidFill>
+            <a:srgbClr val="0F4C6B"/>
+          </a:solidFill>
+          <a:ln/>
+        </p:spPr>
+      </p:sp>
+      <p:sp>
+        <p:nvSpPr>
+          <p:cNvPr id="21" name="Shape 19"/>
           <p:cNvSpPr/>
           <p:nvPr/>
         </p:nvSpPr>
         <p:spPr>
           <a:xfrm>
             <a:off x="6126480" y="2514600"/>
-            <a:ext cx="320040" cy="0"/>
+            <a:ext cx="257175" cy="0"/>
           </a:xfrm>
           <a:prstGeom prst="line">
             <a:avLst/>
@@ -15134,13 +15363,12 @@
               <a:srgbClr val="0F4C6B"/>
             </a:solidFill>
             <a:prstDash val="solid"/>
-            <a:tailEnd type="triangle"/>
           </a:ln>
         </p:spPr>
       </p:sp>
       <p:sp>
         <p:nvSpPr>
-          <p:cNvPr id="19" name="Shape 17"/>
+          <p:cNvPr id="22" name="Shape 20"/>
           <p:cNvSpPr/>
           <p:nvPr/>
         </p:nvSpPr>
@@ -15174,7 +15402,7 @@
       </p:sp>
       <p:sp>
         <p:nvSpPr>
-          <p:cNvPr id="20" name="Text 18"/>
+          <p:cNvPr id="23" name="Text 21"/>
           <p:cNvSpPr txBox="1"/>
           <p:nvPr/>
         </p:nvSpPr>
@@ -15213,7 +15441,7 @@
       </p:sp>
       <p:sp>
         <p:nvSpPr>
-          <p:cNvPr id="21" name="Shape 19"/>
+          <p:cNvPr id="24" name="Shape 22"/>
           <p:cNvSpPr/>
           <p:nvPr/>
         </p:nvSpPr>
@@ -15233,7 +15461,7 @@
       </p:sp>
       <p:sp>
         <p:nvSpPr>
-          <p:cNvPr id="22" name="Text 20"/>
+          <p:cNvPr id="25" name="Text 23"/>
           <p:cNvSpPr txBox="1"/>
           <p:nvPr/>
         </p:nvSpPr>
@@ -15272,14 +15500,34 @@
       </p:sp>
       <p:sp>
         <p:nvSpPr>
-          <p:cNvPr id="23" name="Shape 21"/>
+          <p:cNvPr id="26" name="Shape 24"/>
+          <p:cNvSpPr/>
+          <p:nvPr/>
+        </p:nvSpPr>
+        <p:spPr>
+          <a:xfrm rot="5400000">
+            <a:off x="8926830" y="2451735"/>
+            <a:ext cx="125730" cy="125730"/>
+          </a:xfrm>
+          <a:prstGeom prst="triangle">
+            <a:avLst/>
+          </a:prstGeom>
+          <a:solidFill>
+            <a:srgbClr val="0F4C6B"/>
+          </a:solidFill>
+          <a:ln/>
+        </p:spPr>
+      </p:sp>
+      <p:sp>
+        <p:nvSpPr>
+          <p:cNvPr id="27" name="Shape 25"/>
           <p:cNvSpPr/>
           <p:nvPr/>
         </p:nvSpPr>
         <p:spPr>
           <a:xfrm>
             <a:off x="8732520" y="2514600"/>
-            <a:ext cx="320040" cy="0"/>
+            <a:ext cx="257175" cy="0"/>
           </a:xfrm>
           <a:prstGeom prst="line">
             <a:avLst/>
@@ -15290,13 +15538,12 @@
               <a:srgbClr val="0F4C6B"/>
             </a:solidFill>
             <a:prstDash val="solid"/>
-            <a:tailEnd type="triangle"/>
           </a:ln>
         </p:spPr>
       </p:sp>
       <p:sp>
         <p:nvSpPr>
-          <p:cNvPr id="24" name="Shape 22"/>
+          <p:cNvPr id="28" name="Shape 26"/>
           <p:cNvSpPr/>
           <p:nvPr/>
         </p:nvSpPr>
@@ -15330,7 +15577,7 @@
       </p:sp>
       <p:sp>
         <p:nvSpPr>
-          <p:cNvPr id="25" name="Text 23"/>
+          <p:cNvPr id="29" name="Text 27"/>
           <p:cNvSpPr txBox="1"/>
           <p:nvPr/>
         </p:nvSpPr>
@@ -15369,7 +15616,7 @@
       </p:sp>
       <p:sp>
         <p:nvSpPr>
-          <p:cNvPr id="26" name="Shape 24"/>
+          <p:cNvPr id="30" name="Shape 28"/>
           <p:cNvSpPr/>
           <p:nvPr/>
         </p:nvSpPr>
@@ -15389,7 +15636,7 @@
       </p:sp>
       <p:sp>
         <p:nvSpPr>
-          <p:cNvPr id="27" name="Text 25"/>
+          <p:cNvPr id="31" name="Text 29"/>
           <p:cNvSpPr txBox="1"/>
           <p:nvPr/>
         </p:nvSpPr>
@@ -15428,14 +15675,34 @@
       </p:sp>
       <p:sp>
         <p:nvSpPr>
-          <p:cNvPr id="28" name="Shape 26"/>
+          <p:cNvPr id="32" name="Shape 30"/>
+          <p:cNvSpPr/>
+          <p:nvPr/>
+        </p:nvSpPr>
+        <p:spPr>
+          <a:xfrm rot="10800000">
+            <a:off x="10132695" y="3417570"/>
+            <a:ext cx="125730" cy="125730"/>
+          </a:xfrm>
+          <a:prstGeom prst="triangle">
+            <a:avLst/>
+          </a:prstGeom>
+          <a:solidFill>
+            <a:srgbClr val="0F4C6B"/>
+          </a:solidFill>
+          <a:ln/>
+        </p:spPr>
+      </p:sp>
+      <p:sp>
+        <p:nvSpPr>
+          <p:cNvPr id="33" name="Shape 31"/>
           <p:cNvSpPr/>
           <p:nvPr/>
         </p:nvSpPr>
         <p:spPr>
           <a:xfrm>
             <a:off x="10195560" y="2971800"/>
-            <a:ext cx="0" cy="571500"/>
+            <a:ext cx="0" cy="508635"/>
           </a:xfrm>
           <a:prstGeom prst="line">
             <a:avLst/>
@@ -15446,13 +15713,12 @@
               <a:srgbClr val="0F4C6B"/>
             </a:solidFill>
             <a:prstDash val="solid"/>
-            <a:tailEnd type="triangle"/>
           </a:ln>
         </p:spPr>
       </p:sp>
       <p:sp>
         <p:nvSpPr>
-          <p:cNvPr id="29" name="Shape 27"/>
+          <p:cNvPr id="34" name="Shape 32"/>
           <p:cNvSpPr/>
           <p:nvPr/>
         </p:nvSpPr>
@@ -15477,7 +15743,7 @@
       </p:sp>
       <p:sp>
         <p:nvSpPr>
-          <p:cNvPr id="30" name="Text 28"/>
+          <p:cNvPr id="35" name="Text 33"/>
           <p:cNvSpPr txBox="1"/>
           <p:nvPr/>
         </p:nvSpPr>
@@ -15533,7 +15799,7 @@
       </p:sp>
       <p:sp>
         <p:nvSpPr>
-          <p:cNvPr id="31" name="Shape 29"/>
+          <p:cNvPr id="36" name="Shape 34"/>
           <p:cNvSpPr/>
           <p:nvPr/>
         </p:nvSpPr>
@@ -15567,7 +15833,7 @@
       </p:sp>
       <p:sp>
         <p:nvSpPr>
-          <p:cNvPr id="32" name="Text 30"/>
+          <p:cNvPr id="37" name="Text 35"/>
           <p:cNvSpPr txBox="1"/>
           <p:nvPr/>
         </p:nvSpPr>
@@ -15606,7 +15872,7 @@
       </p:sp>
       <p:sp>
         <p:nvSpPr>
-          <p:cNvPr id="33" name="Shape 31"/>
+          <p:cNvPr id="38" name="Shape 36"/>
           <p:cNvSpPr/>
           <p:nvPr/>
         </p:nvSpPr>
@@ -15640,7 +15906,7 @@
       </p:sp>
       <p:sp>
         <p:nvSpPr>
-          <p:cNvPr id="34" name="Text 32"/>
+          <p:cNvPr id="39" name="Text 37"/>
           <p:cNvSpPr txBox="1"/>
           <p:nvPr/>
         </p:nvSpPr>
@@ -15679,14 +15945,34 @@
       </p:sp>
       <p:sp>
         <p:nvSpPr>
-          <p:cNvPr id="35" name="Shape 33"/>
+          <p:cNvPr id="40" name="Shape 38"/>
+          <p:cNvSpPr/>
+          <p:nvPr/>
+        </p:nvSpPr>
+        <p:spPr>
+          <a:xfrm rot="-3891313">
+            <a:off x="7995043" y="3644307"/>
+            <a:ext cx="125730" cy="125730"/>
+          </a:xfrm>
+          <a:prstGeom prst="triangle">
+            <a:avLst/>
+          </a:prstGeom>
+          <a:solidFill>
+            <a:srgbClr val="0E7C86"/>
+          </a:solidFill>
+          <a:ln/>
+        </p:spPr>
+      </p:sp>
+      <p:sp>
+        <p:nvSpPr>
+          <p:cNvPr id="41" name="Shape 39"/>
           <p:cNvSpPr/>
           <p:nvPr/>
         </p:nvSpPr>
         <p:spPr>
           <a:xfrm flipH="1" flipV="1">
-            <a:off x="8001000" y="3680460"/>
-            <a:ext cx="1120140" cy="525780"/>
+            <a:off x="8057908" y="3707172"/>
+            <a:ext cx="1063232" cy="499068"/>
           </a:xfrm>
           <a:prstGeom prst="line">
             <a:avLst/>
@@ -15697,20 +15983,39 @@
               <a:srgbClr val="0E7C86"/>
             </a:solidFill>
             <a:prstDash val="solid"/>
-            <a:tailEnd type="triangle"/>
           </a:ln>
         </p:spPr>
       </p:sp>
       <p:sp>
         <p:nvSpPr>
-          <p:cNvPr id="36" name="Shape 34"/>
+          <p:cNvPr id="42" name="Shape 40"/>
+          <p:cNvSpPr/>
+          <p:nvPr/>
+        </p:nvSpPr>
+        <p:spPr>
+          <a:xfrm rot="13646199">
+            <a:off x="7984437" y="5129553"/>
+            <a:ext cx="125730" cy="125730"/>
+          </a:xfrm>
+          <a:prstGeom prst="triangle">
+            <a:avLst/>
+          </a:prstGeom>
+          <a:solidFill>
+            <a:srgbClr val="E8553F"/>
+          </a:solidFill>
+          <a:ln/>
+        </p:spPr>
+      </p:sp>
+      <p:sp>
+        <p:nvSpPr>
+          <p:cNvPr id="43" name="Shape 41"/>
           <p:cNvSpPr/>
           <p:nvPr/>
         </p:nvSpPr>
         <p:spPr>
           <a:xfrm flipH="1">
-            <a:off x="8001000" y="4206240"/>
-            <a:ext cx="1120140" cy="1028700"/>
+            <a:off x="8047302" y="4206240"/>
+            <a:ext cx="1073838" cy="986178"/>
           </a:xfrm>
           <a:prstGeom prst="line">
             <a:avLst/>
@@ -15721,13 +16026,12 @@
               <a:srgbClr val="E8553F"/>
             </a:solidFill>
             <a:prstDash val="solid"/>
-            <a:tailEnd type="triangle"/>
           </a:ln>
         </p:spPr>
       </p:sp>
       <p:sp>
         <p:nvSpPr>
-          <p:cNvPr id="37" name="Text 35"/>
+          <p:cNvPr id="44" name="Text 42"/>
           <p:cNvSpPr txBox="1"/>
           <p:nvPr/>
         </p:nvSpPr>
@@ -15766,7 +16070,7 @@
       </p:sp>
       <p:sp>
         <p:nvSpPr>
-          <p:cNvPr id="38" name="Text 36"/>
+          <p:cNvPr id="45" name="Text 43"/>
           <p:cNvSpPr txBox="1"/>
           <p:nvPr/>
         </p:nvSpPr>
@@ -15805,7 +16109,7 @@
       </p:sp>
       <p:sp>
         <p:nvSpPr>
-          <p:cNvPr id="39" name="Shape 37"/>
+          <p:cNvPr id="46" name="Shape 44"/>
           <p:cNvSpPr/>
           <p:nvPr/>
         </p:nvSpPr>
@@ -15839,7 +16143,7 @@
       </p:sp>
       <p:sp>
         <p:nvSpPr>
-          <p:cNvPr id="40" name="Text 38"/>
+          <p:cNvPr id="47" name="Text 45"/>
           <p:cNvSpPr txBox="1"/>
           <p:nvPr/>
         </p:nvSpPr>
@@ -15878,14 +16182,34 @@
       </p:sp>
       <p:sp>
         <p:nvSpPr>
-          <p:cNvPr id="41" name="Shape 39"/>
+          <p:cNvPr id="48" name="Shape 46"/>
+          <p:cNvSpPr/>
+          <p:nvPr/>
+        </p:nvSpPr>
+        <p:spPr>
+          <a:xfrm rot="14057599">
+            <a:off x="4514462" y="4106685"/>
+            <a:ext cx="125730" cy="125730"/>
+          </a:xfrm>
+          <a:prstGeom prst="triangle">
+            <a:avLst/>
+          </a:prstGeom>
+          <a:solidFill>
+            <a:srgbClr val="0F4C6B"/>
+          </a:solidFill>
+          <a:ln/>
+        </p:spPr>
+      </p:sp>
+      <p:sp>
+        <p:nvSpPr>
+          <p:cNvPr id="49" name="Shape 47"/>
           <p:cNvSpPr/>
           <p:nvPr/>
         </p:nvSpPr>
         <p:spPr>
           <a:xfrm flipH="1">
-            <a:off x="4526280" y="3680460"/>
-            <a:ext cx="731520" cy="525780"/>
+            <a:off x="4577327" y="3680460"/>
+            <a:ext cx="680473" cy="489090"/>
           </a:xfrm>
           <a:prstGeom prst="line">
             <a:avLst/>
@@ -15896,20 +16220,39 @@
               <a:srgbClr val="0F4C6B"/>
             </a:solidFill>
             <a:prstDash val="solid"/>
-            <a:tailEnd type="triangle"/>
           </a:ln>
         </p:spPr>
       </p:sp>
       <p:sp>
         <p:nvSpPr>
-          <p:cNvPr id="42" name="Shape 40"/>
+          <p:cNvPr id="50" name="Shape 48"/>
+          <p:cNvSpPr/>
+          <p:nvPr/>
+        </p:nvSpPr>
+        <p:spPr>
+          <a:xfrm rot="-2125023">
+            <a:off x="4499847" y="4194607"/>
+            <a:ext cx="125730" cy="125730"/>
+          </a:xfrm>
+          <a:prstGeom prst="triangle">
+            <a:avLst/>
+          </a:prstGeom>
+          <a:solidFill>
+            <a:srgbClr val="0F4C6B"/>
+          </a:solidFill>
+          <a:ln/>
+        </p:spPr>
+      </p:sp>
+      <p:sp>
+        <p:nvSpPr>
+          <p:cNvPr id="51" name="Shape 49"/>
           <p:cNvSpPr/>
           <p:nvPr/>
         </p:nvSpPr>
         <p:spPr>
           <a:xfrm flipH="1" flipV="1">
-            <a:off x="4526280" y="4206240"/>
-            <a:ext cx="731520" cy="1028700"/>
+            <a:off x="4562712" y="4257472"/>
+            <a:ext cx="695088" cy="977468"/>
           </a:xfrm>
           <a:prstGeom prst="line">
             <a:avLst/>
@@ -15920,20 +16263,39 @@
               <a:srgbClr val="0F4C6B"/>
             </a:solidFill>
             <a:prstDash val="solid"/>
-            <a:tailEnd type="triangle"/>
           </a:ln>
         </p:spPr>
       </p:sp>
       <p:sp>
         <p:nvSpPr>
-          <p:cNvPr id="43" name="Shape 41"/>
+          <p:cNvPr id="52" name="Shape 50"/>
+          <p:cNvSpPr/>
+          <p:nvPr/>
+        </p:nvSpPr>
+        <p:spPr>
+          <a:xfrm rot="16200000">
+            <a:off x="1417320" y="4143375"/>
+            <a:ext cx="125730" cy="125730"/>
+          </a:xfrm>
+          <a:prstGeom prst="triangle">
+            <a:avLst/>
+          </a:prstGeom>
+          <a:solidFill>
+            <a:srgbClr val="0F4C6B"/>
+          </a:solidFill>
+          <a:ln/>
+        </p:spPr>
+      </p:sp>
+      <p:sp>
+        <p:nvSpPr>
+          <p:cNvPr id="53" name="Shape 51"/>
           <p:cNvSpPr/>
           <p:nvPr/>
         </p:nvSpPr>
         <p:spPr>
           <a:xfrm flipH="1">
-            <a:off x="1417320" y="4206240"/>
-            <a:ext cx="685800" cy="0"/>
+            <a:off x="1480185" y="4206240"/>
+            <a:ext cx="622935" cy="0"/>
           </a:xfrm>
           <a:prstGeom prst="line">
             <a:avLst/>
@@ -15944,13 +16306,12 @@
               <a:srgbClr val="0F4C6B"/>
             </a:solidFill>
             <a:prstDash val="solid"/>
-            <a:tailEnd type="triangle"/>
           </a:ln>
         </p:spPr>
       </p:sp>
       <p:sp>
         <p:nvSpPr>
-          <p:cNvPr id="44" name="Shape 42"/>
+          <p:cNvPr id="54" name="Shape 52"/>
           <p:cNvSpPr/>
           <p:nvPr/>
         </p:nvSpPr>
@@ -15975,7 +16336,7 @@
       </p:sp>
       <p:sp>
         <p:nvSpPr>
-          <p:cNvPr id="45" name="Shape 43"/>
+          <p:cNvPr id="55" name="Shape 53"/>
           <p:cNvSpPr/>
           <p:nvPr/>
         </p:nvSpPr>
@@ -15995,7 +16356,7 @@
       </p:sp>
       <p:sp>
         <p:nvSpPr>
-          <p:cNvPr id="46" name="Text 44"/>
+          <p:cNvPr id="56" name="Text 54"/>
           <p:cNvSpPr txBox="1"/>
           <p:nvPr/>
         </p:nvSpPr>
@@ -16034,7 +16395,7 @@
       </p:sp>
       <p:sp>
         <p:nvSpPr>
-          <p:cNvPr id="47" name="Shape 45"/>
+          <p:cNvPr id="57" name="Shape 55"/>
           <p:cNvSpPr/>
           <p:nvPr/>
         </p:nvSpPr>
@@ -16056,7 +16417,7 @@
       </p:sp>
       <p:sp>
         <p:nvSpPr>
-          <p:cNvPr id="48" name="Text 46"/>
+          <p:cNvPr id="58" name="Text 56"/>
           <p:cNvSpPr txBox="1"/>
           <p:nvPr/>
         </p:nvSpPr>
@@ -16109,7 +16470,7 @@
       </p:sp>
       <p:sp>
         <p:nvSpPr>
-          <p:cNvPr id="49" name="Text 47"/>
+          <p:cNvPr id="59" name="Text 57"/>
           <p:cNvSpPr txBox="1"/>
           <p:nvPr/>
         </p:nvSpPr>
@@ -16148,7 +16509,7 @@
       </p:sp>
       <p:sp>
         <p:nvSpPr>
-          <p:cNvPr id="50" name="Text 48"/>
+          <p:cNvPr id="60" name="Text 58"/>
           <p:cNvSpPr txBox="1"/>
           <p:nvPr/>
         </p:nvSpPr>
@@ -26002,724 +26363,29 @@
           <p:nvPr/>
         </p:nvSpPr>
         <p:spPr>
+          <a:xfrm rot="5400000">
+            <a:off x="3550158" y="2726055"/>
+            <a:ext cx="125730" cy="125730"/>
+          </a:xfrm>
+          <a:prstGeom prst="triangle">
+            <a:avLst/>
+          </a:prstGeom>
+          <a:solidFill>
+            <a:srgbClr val="0B2A45"/>
+          </a:solidFill>
+          <a:ln/>
+        </p:spPr>
+      </p:sp>
+      <p:sp>
+        <p:nvSpPr>
+          <p:cNvPr id="28" name="Shape 21"/>
+          <p:cNvSpPr/>
+          <p:nvPr/>
+        </p:nvSpPr>
+        <p:spPr>
           <a:xfrm>
             <a:off x="1417320" y="2788920"/>
-            <a:ext cx="2258568" cy="0"/>
-          </a:xfrm>
-          <a:prstGeom prst="line">
-            <a:avLst/>
-          </a:prstGeom>
-          <a:noFill/>
-          <a:ln w="19050">
-            <a:solidFill>
-              <a:srgbClr val="0B2A45"/>
-            </a:solidFill>
-            <a:prstDash val="solid"/>
-            <a:tailEnd type="triangle"/>
-          </a:ln>
-        </p:spPr>
-      </p:sp>
-      <p:sp>
-        <p:nvSpPr>
-          <p:cNvPr id="28" name="Text 21"/>
-          <p:cNvSpPr txBox="1"/>
-          <p:nvPr/>
-        </p:nvSpPr>
-        <p:spPr>
-          <a:xfrm>
-            <a:off x="1618488" y="2569464"/>
-            <a:ext cx="950976" cy="192024"/>
-          </a:xfrm>
-          <a:prstGeom prst="rect">
-            <a:avLst/>
-          </a:prstGeom>
-          <a:solidFill>
-            <a:srgbClr val="FFFFFF"/>
-          </a:solidFill>
-          <a:ln/>
-        </p:spPr>
-        <p:txBody>
-          <a:bodyPr wrap="square" lIns="0" tIns="25400" rIns="25400" bIns="0" rtlCol="0" anchor="ctr"/>
-          <a:lstStyle/>
-          <a:p>
-            <a:pPr indent="0" marL="0">
-              <a:buNone/>
-            </a:pPr>
-            <a:r>
-              <a:rPr lang="en-US" sz="900" b="1" dirty="0">
-                <a:solidFill>
-                  <a:srgbClr val="0B2A45"/>
-                </a:solidFill>
-                <a:latin typeface="Open Sans" pitchFamily="34" charset="0"/>
-                <a:ea typeface="Open Sans" pitchFamily="34" charset="-122"/>
-                <a:cs typeface="Open Sans" pitchFamily="34" charset="-120"/>
-              </a:rPr>
-              <a:t>1. GPS datos</a:t>
-            </a:r>
-            <a:endParaRPr lang="en-US" sz="900" dirty="0"/>
-          </a:p>
-        </p:txBody>
-      </p:sp>
-      <p:sp>
-        <p:nvSpPr>
-          <p:cNvPr id="29" name="Shape 22"/>
-          <p:cNvSpPr/>
-          <p:nvPr/>
-        </p:nvSpPr>
-        <p:spPr>
-          <a:xfrm>
-            <a:off x="3822192" y="3090672"/>
-            <a:ext cx="2258568" cy="0"/>
-          </a:xfrm>
-          <a:prstGeom prst="line">
-            <a:avLst/>
-          </a:prstGeom>
-          <a:noFill/>
-          <a:ln w="19050">
-            <a:solidFill>
-              <a:srgbClr val="0B2A45"/>
-            </a:solidFill>
-            <a:prstDash val="solid"/>
-            <a:tailEnd type="triangle"/>
-          </a:ln>
-        </p:spPr>
-      </p:sp>
-      <p:sp>
-        <p:nvSpPr>
-          <p:cNvPr id="30" name="Text 23"/>
-          <p:cNvSpPr txBox="1"/>
-          <p:nvPr/>
-        </p:nvSpPr>
-        <p:spPr>
-          <a:xfrm>
-            <a:off x="4023360" y="2871216"/>
-            <a:ext cx="822960" cy="192024"/>
-          </a:xfrm>
-          <a:prstGeom prst="rect">
-            <a:avLst/>
-          </a:prstGeom>
-          <a:solidFill>
-            <a:srgbClr val="FFFFFF"/>
-          </a:solidFill>
-          <a:ln/>
-        </p:spPr>
-        <p:txBody>
-          <a:bodyPr wrap="square" lIns="0" tIns="25400" rIns="25400" bIns="0" rtlCol="0" anchor="ctr"/>
-          <a:lstStyle/>
-          <a:p>
-            <a:pPr indent="0" marL="0">
-              <a:buNone/>
-            </a:pPr>
-            <a:r>
-              <a:rPr lang="en-US" sz="900" b="1" dirty="0">
-                <a:solidFill>
-                  <a:srgbClr val="0B2A45"/>
-                </a:solidFill>
-                <a:latin typeface="Open Sans" pitchFamily="34" charset="0"/>
-                <a:ea typeface="Open Sans" pitchFamily="34" charset="-122"/>
-                <a:cs typeface="Open Sans" pitchFamily="34" charset="-120"/>
-              </a:rPr>
-              <a:t>2. Validar</a:t>
-            </a:r>
-            <a:endParaRPr lang="en-US" sz="900" dirty="0"/>
-          </a:p>
-        </p:txBody>
-      </p:sp>
-      <p:sp>
-        <p:nvSpPr>
-          <p:cNvPr id="31" name="Shape 24"/>
-          <p:cNvSpPr/>
-          <p:nvPr/>
-        </p:nvSpPr>
-        <p:spPr>
-          <a:xfrm flipH="1">
-            <a:off x="3822192" y="3392424"/>
-            <a:ext cx="2258568" cy="0"/>
-          </a:xfrm>
-          <a:prstGeom prst="line">
-            <a:avLst/>
-          </a:prstGeom>
-          <a:noFill/>
-          <a:ln w="19050">
-            <a:solidFill>
-              <a:srgbClr val="5A6B7B"/>
-            </a:solidFill>
-            <a:prstDash val="dash"/>
-            <a:tailEnd type="triangle"/>
-          </a:ln>
-        </p:spPr>
-      </p:sp>
-      <p:sp>
-        <p:nvSpPr>
-          <p:cNvPr id="32" name="Text 25"/>
-          <p:cNvSpPr txBox="1"/>
-          <p:nvPr/>
-        </p:nvSpPr>
-        <p:spPr>
-          <a:xfrm>
-            <a:off x="4023360" y="3172968"/>
-            <a:ext cx="950976" cy="192024"/>
-          </a:xfrm>
-          <a:prstGeom prst="rect">
-            <a:avLst/>
-          </a:prstGeom>
-          <a:solidFill>
-            <a:srgbClr val="FFFFFF"/>
-          </a:solidFill>
-          <a:ln/>
-        </p:spPr>
-        <p:txBody>
-          <a:bodyPr wrap="square" lIns="0" tIns="25400" rIns="25400" bIns="0" rtlCol="0" anchor="ctr"/>
-          <a:lstStyle/>
-          <a:p>
-            <a:pPr indent="0" marL="0">
-              <a:buNone/>
-            </a:pPr>
-            <a:r>
-              <a:rPr lang="en-US" sz="900" b="1" dirty="0">
-                <a:solidFill>
-                  <a:srgbClr val="5A6B7B"/>
-                </a:solidFill>
-                <a:latin typeface="Open Sans" pitchFamily="34" charset="0"/>
-                <a:ea typeface="Open Sans" pitchFamily="34" charset="-122"/>
-                <a:cs typeface="Open Sans" pitchFamily="34" charset="-120"/>
-              </a:rPr>
-              <a:t>3. Respuesta</a:t>
-            </a:r>
-            <a:endParaRPr lang="en-US" sz="900" dirty="0"/>
-          </a:p>
-        </p:txBody>
-      </p:sp>
-      <p:sp>
-        <p:nvSpPr>
-          <p:cNvPr id="33" name="Shape 26"/>
-          <p:cNvSpPr/>
-          <p:nvPr/>
-        </p:nvSpPr>
-        <p:spPr>
-          <a:xfrm>
-            <a:off x="3822192" y="3694176"/>
-            <a:ext cx="4590288" cy="0"/>
-          </a:xfrm>
-          <a:prstGeom prst="line">
-            <a:avLst/>
-          </a:prstGeom>
-          <a:noFill/>
-          <a:ln w="19050">
-            <a:solidFill>
-              <a:srgbClr val="E8553F"/>
-            </a:solidFill>
-            <a:prstDash val="solid"/>
-            <a:tailEnd type="triangle"/>
-          </a:ln>
-        </p:spPr>
-      </p:sp>
-      <p:sp>
-        <p:nvSpPr>
-          <p:cNvPr id="34" name="Text 27"/>
-          <p:cNvSpPr txBox="1"/>
-          <p:nvPr/>
-        </p:nvSpPr>
-        <p:spPr>
-          <a:xfrm>
-            <a:off x="4023360" y="3474720"/>
-            <a:ext cx="758952" cy="192024"/>
-          </a:xfrm>
-          <a:prstGeom prst="rect">
-            <a:avLst/>
-          </a:prstGeom>
-          <a:solidFill>
-            <a:srgbClr val="FFFFFF"/>
-          </a:solidFill>
-          <a:ln/>
-        </p:spPr>
-        <p:txBody>
-          <a:bodyPr wrap="square" lIns="0" tIns="25400" rIns="25400" bIns="0" rtlCol="0" anchor="ctr"/>
-          <a:lstStyle/>
-          <a:p>
-            <a:pPr indent="0" marL="0">
-              <a:buNone/>
-            </a:pPr>
-            <a:r>
-              <a:rPr lang="en-US" sz="900" b="1" dirty="0">
-                <a:solidFill>
-                  <a:srgbClr val="E8553F"/>
-                </a:solidFill>
-                <a:latin typeface="Open Sans" pitchFamily="34" charset="0"/>
-                <a:ea typeface="Open Sans" pitchFamily="34" charset="-122"/>
-                <a:cs typeface="Open Sans" pitchFamily="34" charset="-120"/>
-              </a:rPr>
-              <a:t>4. Alerta</a:t>
-            </a:r>
-            <a:endParaRPr lang="en-US" sz="900" dirty="0"/>
-          </a:p>
-        </p:txBody>
-      </p:sp>
-      <p:sp>
-        <p:nvSpPr>
-          <p:cNvPr id="35" name="Shape 28"/>
-          <p:cNvSpPr/>
-          <p:nvPr/>
-        </p:nvSpPr>
-        <p:spPr>
-          <a:xfrm>
-            <a:off x="3822192" y="3995928"/>
-            <a:ext cx="6922008" cy="0"/>
-          </a:xfrm>
-          <a:prstGeom prst="line">
-            <a:avLst/>
-          </a:prstGeom>
-          <a:noFill/>
-          <a:ln w="19050">
-            <a:solidFill>
-              <a:srgbClr val="E8553F"/>
-            </a:solidFill>
-            <a:prstDash val="solid"/>
-            <a:tailEnd type="triangle"/>
-          </a:ln>
-        </p:spPr>
-      </p:sp>
-      <p:sp>
-        <p:nvSpPr>
-          <p:cNvPr id="36" name="Text 29"/>
-          <p:cNvSpPr txBox="1"/>
-          <p:nvPr/>
-        </p:nvSpPr>
-        <p:spPr>
-          <a:xfrm>
-            <a:off x="4023360" y="3776472"/>
-            <a:ext cx="758952" cy="192024"/>
-          </a:xfrm>
-          <a:prstGeom prst="rect">
-            <a:avLst/>
-          </a:prstGeom>
-          <a:solidFill>
-            <a:srgbClr val="FFFFFF"/>
-          </a:solidFill>
-          <a:ln/>
-        </p:spPr>
-        <p:txBody>
-          <a:bodyPr wrap="square" lIns="0" tIns="25400" rIns="25400" bIns="0" rtlCol="0" anchor="ctr"/>
-          <a:lstStyle/>
-          <a:p>
-            <a:pPr indent="0" marL="0">
-              <a:buNone/>
-            </a:pPr>
-            <a:r>
-              <a:rPr lang="en-US" sz="900" b="1" dirty="0">
-                <a:solidFill>
-                  <a:srgbClr val="E8553F"/>
-                </a:solidFill>
-                <a:latin typeface="Open Sans" pitchFamily="34" charset="0"/>
-                <a:ea typeface="Open Sans" pitchFamily="34" charset="-122"/>
-                <a:cs typeface="Open Sans" pitchFamily="34" charset="-120"/>
-              </a:rPr>
-              <a:t>5. Alerta</a:t>
-            </a:r>
-            <a:endParaRPr lang="en-US" sz="900" dirty="0"/>
-          </a:p>
-        </p:txBody>
-      </p:sp>
-      <p:sp>
-        <p:nvSpPr>
-          <p:cNvPr id="37" name="Shape 30"/>
-          <p:cNvSpPr/>
-          <p:nvPr/>
-        </p:nvSpPr>
-        <p:spPr>
-          <a:xfrm>
-            <a:off x="1417320" y="4297680"/>
-            <a:ext cx="2258568" cy="0"/>
-          </a:xfrm>
-          <a:prstGeom prst="line">
-            <a:avLst/>
-          </a:prstGeom>
-          <a:noFill/>
-          <a:ln w="19050">
-            <a:solidFill>
-              <a:srgbClr val="0B2A45"/>
-            </a:solidFill>
-            <a:prstDash val="solid"/>
-            <a:tailEnd type="triangle"/>
-          </a:ln>
-        </p:spPr>
-      </p:sp>
-      <p:sp>
-        <p:nvSpPr>
-          <p:cNvPr id="38" name="Text 31"/>
-          <p:cNvSpPr txBox="1"/>
-          <p:nvPr/>
-        </p:nvSpPr>
-        <p:spPr>
-          <a:xfrm>
-            <a:off x="1618488" y="4078224"/>
-            <a:ext cx="1335024" cy="192024"/>
-          </a:xfrm>
-          <a:prstGeom prst="rect">
-            <a:avLst/>
-          </a:prstGeom>
-          <a:solidFill>
-            <a:srgbClr val="FFFFFF"/>
-          </a:solidFill>
-          <a:ln/>
-        </p:spPr>
-        <p:txBody>
-          <a:bodyPr wrap="square" lIns="0" tIns="25400" rIns="25400" bIns="0" rtlCol="0" anchor="ctr"/>
-          <a:lstStyle/>
-          <a:p>
-            <a:pPr indent="0" marL="0">
-              <a:buNone/>
-            </a:pPr>
-            <a:r>
-              <a:rPr lang="en-US" sz="900" b="1" dirty="0">
-                <a:solidFill>
-                  <a:srgbClr val="0B2A45"/>
-                </a:solidFill>
-                <a:latin typeface="Open Sans" pitchFamily="34" charset="0"/>
-                <a:ea typeface="Open Sans" pitchFamily="34" charset="-122"/>
-                <a:cs typeface="Open Sans" pitchFamily="34" charset="-120"/>
-              </a:rPr>
-              <a:t>6. Bitácora, fotos</a:t>
-            </a:r>
-            <a:endParaRPr lang="en-US" sz="900" dirty="0"/>
-          </a:p>
-        </p:txBody>
-      </p:sp>
-      <p:sp>
-        <p:nvSpPr>
-          <p:cNvPr id="39" name="Shape 32"/>
-          <p:cNvSpPr/>
-          <p:nvPr/>
-        </p:nvSpPr>
-        <p:spPr>
-          <a:xfrm flipH="1">
-            <a:off x="3822192" y="4599432"/>
-            <a:ext cx="2258568" cy="0"/>
-          </a:xfrm>
-          <a:prstGeom prst="line">
-            <a:avLst/>
-          </a:prstGeom>
-          <a:noFill/>
-          <a:ln w="19050">
-            <a:solidFill>
-              <a:srgbClr val="5A6B7B"/>
-            </a:solidFill>
-            <a:prstDash val="dash"/>
-            <a:tailEnd type="triangle"/>
-          </a:ln>
-        </p:spPr>
-      </p:sp>
-      <p:sp>
-        <p:nvSpPr>
-          <p:cNvPr id="40" name="Text 33"/>
-          <p:cNvSpPr txBox="1"/>
-          <p:nvPr/>
-        </p:nvSpPr>
-        <p:spPr>
-          <a:xfrm>
-            <a:off x="4023360" y="4379976"/>
-            <a:ext cx="1143000" cy="192024"/>
-          </a:xfrm>
-          <a:prstGeom prst="rect">
-            <a:avLst/>
-          </a:prstGeom>
-          <a:solidFill>
-            <a:srgbClr val="FFFFFF"/>
-          </a:solidFill>
-          <a:ln/>
-        </p:spPr>
-        <p:txBody>
-          <a:bodyPr wrap="square" lIns="0" tIns="25400" rIns="25400" bIns="0" rtlCol="0" anchor="ctr"/>
-          <a:lstStyle/>
-          <a:p>
-            <a:pPr indent="0" marL="0">
-              <a:buNone/>
-            </a:pPr>
-            <a:r>
-              <a:rPr lang="en-US" sz="900" b="1" dirty="0">
-                <a:solidFill>
-                  <a:srgbClr val="5A6B7B"/>
-                </a:solidFill>
-                <a:latin typeface="Open Sans" pitchFamily="34" charset="0"/>
-                <a:ea typeface="Open Sans" pitchFamily="34" charset="-122"/>
-                <a:cs typeface="Open Sans" pitchFamily="34" charset="-120"/>
-              </a:rPr>
-              <a:t>7. Confirmación</a:t>
-            </a:r>
-            <a:endParaRPr lang="en-US" sz="900" dirty="0"/>
-          </a:p>
-        </p:txBody>
-      </p:sp>
-      <p:sp>
-        <p:nvSpPr>
-          <p:cNvPr id="41" name="Shape 34"/>
-          <p:cNvSpPr/>
-          <p:nvPr/>
-        </p:nvSpPr>
-        <p:spPr>
-          <a:xfrm>
-            <a:off x="3822192" y="4901184"/>
-            <a:ext cx="2258568" cy="0"/>
-          </a:xfrm>
-          <a:prstGeom prst="line">
-            <a:avLst/>
-          </a:prstGeom>
-          <a:noFill/>
-          <a:ln w="19050">
-            <a:solidFill>
-              <a:srgbClr val="0B2A45"/>
-            </a:solidFill>
-            <a:prstDash val="solid"/>
-            <a:tailEnd type="triangle"/>
-          </a:ln>
-        </p:spPr>
-      </p:sp>
-      <p:sp>
-        <p:nvSpPr>
-          <p:cNvPr id="42" name="Text 35"/>
-          <p:cNvSpPr txBox="1"/>
-          <p:nvPr/>
-        </p:nvSpPr>
-        <p:spPr>
-          <a:xfrm>
-            <a:off x="4023360" y="4681728"/>
-            <a:ext cx="1078992" cy="192024"/>
-          </a:xfrm>
-          <a:prstGeom prst="rect">
-            <a:avLst/>
-          </a:prstGeom>
-          <a:solidFill>
-            <a:srgbClr val="FFFFFF"/>
-          </a:solidFill>
-          <a:ln/>
-        </p:spPr>
-        <p:txBody>
-          <a:bodyPr wrap="square" lIns="0" tIns="25400" rIns="25400" bIns="0" rtlCol="0" anchor="ctr"/>
-          <a:lstStyle/>
-          <a:p>
-            <a:pPr indent="0" marL="0">
-              <a:buNone/>
-            </a:pPr>
-            <a:r>
-              <a:rPr lang="en-US" sz="900" b="1" dirty="0">
-                <a:solidFill>
-                  <a:srgbClr val="0B2A45"/>
-                </a:solidFill>
-                <a:latin typeface="Open Sans" pitchFamily="34" charset="0"/>
-                <a:ea typeface="Open Sans" pitchFamily="34" charset="-122"/>
-                <a:cs typeface="Open Sans" pitchFamily="34" charset="-120"/>
-              </a:rPr>
-              <a:t>8. QR generado</a:t>
-            </a:r>
-            <a:endParaRPr lang="en-US" sz="900" dirty="0"/>
-          </a:p>
-        </p:txBody>
-      </p:sp>
-      <p:sp>
-        <p:nvSpPr>
-          <p:cNvPr id="43" name="Shape 36"/>
-          <p:cNvSpPr/>
-          <p:nvPr/>
-        </p:nvSpPr>
-        <p:spPr>
-          <a:xfrm>
-            <a:off x="3822192" y="5202936"/>
-            <a:ext cx="4590288" cy="0"/>
-          </a:xfrm>
-          <a:prstGeom prst="line">
-            <a:avLst/>
-          </a:prstGeom>
-          <a:noFill/>
-          <a:ln w="19050">
-            <a:solidFill>
-              <a:srgbClr val="0E7C86"/>
-            </a:solidFill>
-            <a:prstDash val="solid"/>
-            <a:tailEnd type="triangle"/>
-          </a:ln>
-        </p:spPr>
-      </p:sp>
-      <p:sp>
-        <p:nvSpPr>
-          <p:cNvPr id="44" name="Text 37"/>
-          <p:cNvSpPr txBox="1"/>
-          <p:nvPr/>
-        </p:nvSpPr>
-        <p:spPr>
-          <a:xfrm>
-            <a:off x="4023360" y="4983480"/>
-            <a:ext cx="822960" cy="192024"/>
-          </a:xfrm>
-          <a:prstGeom prst="rect">
-            <a:avLst/>
-          </a:prstGeom>
-          <a:solidFill>
-            <a:srgbClr val="FFFFFF"/>
-          </a:solidFill>
-          <a:ln/>
-        </p:spPr>
-        <p:txBody>
-          <a:bodyPr wrap="square" lIns="0" tIns="25400" rIns="25400" bIns="0" rtlCol="0" anchor="ctr"/>
-          <a:lstStyle/>
-          <a:p>
-            <a:pPr indent="0" marL="0">
-              <a:buNone/>
-            </a:pPr>
-            <a:r>
-              <a:rPr lang="en-US" sz="900" b="1" dirty="0">
-                <a:solidFill>
-                  <a:srgbClr val="0E7C86"/>
-                </a:solidFill>
-                <a:latin typeface="Open Sans" pitchFamily="34" charset="0"/>
-                <a:ea typeface="Open Sans" pitchFamily="34" charset="-122"/>
-                <a:cs typeface="Open Sans" pitchFamily="34" charset="-120"/>
-              </a:rPr>
-              <a:t>9. Reporte</a:t>
-            </a:r>
-            <a:endParaRPr lang="en-US" sz="900" dirty="0"/>
-          </a:p>
-        </p:txBody>
-      </p:sp>
-      <p:sp>
-        <p:nvSpPr>
-          <p:cNvPr id="45" name="Shape 38"/>
-          <p:cNvSpPr/>
-          <p:nvPr/>
-        </p:nvSpPr>
-        <p:spPr>
-          <a:xfrm>
-            <a:off x="3822192" y="5504688"/>
-            <a:ext cx="6922008" cy="0"/>
-          </a:xfrm>
-          <a:prstGeom prst="line">
-            <a:avLst/>
-          </a:prstGeom>
-          <a:noFill/>
-          <a:ln w="19050">
-            <a:solidFill>
-              <a:srgbClr val="0E7C86"/>
-            </a:solidFill>
-            <a:prstDash val="solid"/>
-            <a:tailEnd type="triangle"/>
-          </a:ln>
-        </p:spPr>
-      </p:sp>
-      <p:sp>
-        <p:nvSpPr>
-          <p:cNvPr id="46" name="Text 39"/>
-          <p:cNvSpPr txBox="1"/>
-          <p:nvPr/>
-        </p:nvSpPr>
-        <p:spPr>
-          <a:xfrm>
-            <a:off x="4023360" y="5285232"/>
-            <a:ext cx="886968" cy="192024"/>
-          </a:xfrm>
-          <a:prstGeom prst="rect">
-            <a:avLst/>
-          </a:prstGeom>
-          <a:solidFill>
-            <a:srgbClr val="FFFFFF"/>
-          </a:solidFill>
-          <a:ln/>
-        </p:spPr>
-        <p:txBody>
-          <a:bodyPr wrap="square" lIns="0" tIns="25400" rIns="25400" bIns="0" rtlCol="0" anchor="ctr"/>
-          <a:lstStyle/>
-          <a:p>
-            <a:pPr indent="0" marL="0">
-              <a:buNone/>
-            </a:pPr>
-            <a:r>
-              <a:rPr lang="en-US" sz="900" b="1" dirty="0">
-                <a:solidFill>
-                  <a:srgbClr val="0E7C86"/>
-                </a:solidFill>
-                <a:latin typeface="Open Sans" pitchFamily="34" charset="0"/>
-                <a:ea typeface="Open Sans" pitchFamily="34" charset="-122"/>
-                <a:cs typeface="Open Sans" pitchFamily="34" charset="-120"/>
-              </a:rPr>
-              <a:t>10. Reporte</a:t>
-            </a:r>
-            <a:endParaRPr lang="en-US" sz="900" dirty="0"/>
-          </a:p>
-        </p:txBody>
-      </p:sp>
-      <p:sp>
-        <p:nvSpPr>
-          <p:cNvPr id="47" name="Shape 40"/>
-          <p:cNvSpPr/>
-          <p:nvPr/>
-        </p:nvSpPr>
-        <p:spPr>
-          <a:xfrm flipH="1">
-            <a:off x="1417320" y="5806440"/>
-            <a:ext cx="2258568" cy="0"/>
-          </a:xfrm>
-          <a:prstGeom prst="line">
-            <a:avLst/>
-          </a:prstGeom>
-          <a:noFill/>
-          <a:ln w="19050">
-            <a:solidFill>
-              <a:srgbClr val="0B2A45"/>
-            </a:solidFill>
-            <a:prstDash val="solid"/>
-            <a:tailEnd type="triangle"/>
-          </a:ln>
-        </p:spPr>
-      </p:sp>
-      <p:sp>
-        <p:nvSpPr>
-          <p:cNvPr id="48" name="Text 41"/>
-          <p:cNvSpPr txBox="1"/>
-          <p:nvPr/>
-        </p:nvSpPr>
-        <p:spPr>
-          <a:xfrm>
-            <a:off x="1618488" y="5586984"/>
-            <a:ext cx="1207008" cy="192024"/>
-          </a:xfrm>
-          <a:prstGeom prst="rect">
-            <a:avLst/>
-          </a:prstGeom>
-          <a:solidFill>
-            <a:srgbClr val="FFFFFF"/>
-          </a:solidFill>
-          <a:ln/>
-        </p:spPr>
-        <p:txBody>
-          <a:bodyPr wrap="square" lIns="0" tIns="25400" rIns="25400" bIns="0" rtlCol="0" anchor="ctr"/>
-          <a:lstStyle/>
-          <a:p>
-            <a:pPr indent="0" marL="0">
-              <a:buNone/>
-            </a:pPr>
-            <a:r>
-              <a:rPr lang="en-US" sz="900" b="1" dirty="0">
-                <a:solidFill>
-                  <a:srgbClr val="0B2A45"/>
-                </a:solidFill>
-                <a:latin typeface="Open Sans" pitchFamily="34" charset="0"/>
-                <a:ea typeface="Open Sans" pitchFamily="34" charset="-122"/>
-                <a:cs typeface="Open Sans" pitchFamily="34" charset="-120"/>
-              </a:rPr>
-              <a:t>11. Notificación</a:t>
-            </a:r>
-            <a:endParaRPr lang="en-US" sz="900" dirty="0"/>
-          </a:p>
-        </p:txBody>
-      </p:sp>
-      <p:sp>
-        <p:nvSpPr>
-          <p:cNvPr id="49" name="Shape 42"/>
-          <p:cNvSpPr/>
-          <p:nvPr/>
-        </p:nvSpPr>
-        <p:spPr>
-          <a:xfrm>
-            <a:off x="5852160" y="6217920"/>
-            <a:ext cx="365760" cy="0"/>
+            <a:ext cx="2195703" cy="0"/>
           </a:xfrm>
           <a:prstGeom prst="line">
             <a:avLst/>
@@ -26735,38 +26401,40 @@
       </p:sp>
       <p:sp>
         <p:nvSpPr>
-          <p:cNvPr id="50" name="Text 43"/>
-          <p:cNvSpPr txBox="1"/>
-          <p:nvPr/>
-        </p:nvSpPr>
-        <p:spPr>
-          <a:xfrm>
-            <a:off x="6291072" y="6108192"/>
-            <a:ext cx="914400" cy="228600"/>
-          </a:xfrm>
-          <a:prstGeom prst="rect">
-            <a:avLst/>
-          </a:prstGeom>
-          <a:noFill/>
-          <a:ln/>
-        </p:spPr>
-        <p:txBody>
-          <a:bodyPr wrap="square" lIns="0" tIns="0" rIns="0" bIns="0" rtlCol="0" anchor="ctr"/>
-          <a:lstStyle/>
-          <a:p>
-            <a:pPr indent="0" marL="0">
-              <a:buNone/>
-            </a:pPr>
-            <a:r>
-              <a:rPr lang="en-US" sz="900" dirty="0">
-                <a:solidFill>
-                  <a:srgbClr val="5A6B7B"/>
+          <p:cNvPr id="29" name="Text 22"/>
+          <p:cNvSpPr txBox="1"/>
+          <p:nvPr/>
+        </p:nvSpPr>
+        <p:spPr>
+          <a:xfrm>
+            <a:off x="1618488" y="2569464"/>
+            <a:ext cx="950976" cy="192024"/>
+          </a:xfrm>
+          <a:prstGeom prst="rect">
+            <a:avLst/>
+          </a:prstGeom>
+          <a:solidFill>
+            <a:srgbClr val="FFFFFF"/>
+          </a:solidFill>
+          <a:ln/>
+        </p:spPr>
+        <p:txBody>
+          <a:bodyPr wrap="square" lIns="0" tIns="25400" rIns="25400" bIns="0" rtlCol="0" anchor="ctr"/>
+          <a:lstStyle/>
+          <a:p>
+            <a:pPr indent="0" marL="0">
+              <a:buNone/>
+            </a:pPr>
+            <a:r>
+              <a:rPr lang="en-US" sz="900" b="1" dirty="0">
+                <a:solidFill>
+                  <a:srgbClr val="0B2A45"/>
                 </a:solidFill>
                 <a:latin typeface="Open Sans" pitchFamily="34" charset="0"/>
                 <a:ea typeface="Open Sans" pitchFamily="34" charset="-122"/>
                 <a:cs typeface="Open Sans" pitchFamily="34" charset="-120"/>
               </a:rPr>
-              <a:t>Llamada</a:t>
+              <a:t>1. GPS datos</a:t>
             </a:r>
             <a:endParaRPr lang="en-US" sz="900" dirty="0"/>
           </a:p>
@@ -26774,14 +26442,118 @@
       </p:sp>
       <p:sp>
         <p:nvSpPr>
-          <p:cNvPr id="51" name="Shape 44"/>
-          <p:cNvSpPr/>
-          <p:nvPr/>
-        </p:nvSpPr>
-        <p:spPr>
-          <a:xfrm>
-            <a:off x="7269480" y="6217920"/>
-            <a:ext cx="365760" cy="0"/>
+          <p:cNvPr id="30" name="Shape 23"/>
+          <p:cNvSpPr/>
+          <p:nvPr/>
+        </p:nvSpPr>
+        <p:spPr>
+          <a:xfrm rot="5400000">
+            <a:off x="5955030" y="3027807"/>
+            <a:ext cx="125730" cy="125730"/>
+          </a:xfrm>
+          <a:prstGeom prst="triangle">
+            <a:avLst/>
+          </a:prstGeom>
+          <a:solidFill>
+            <a:srgbClr val="0B2A45"/>
+          </a:solidFill>
+          <a:ln/>
+        </p:spPr>
+      </p:sp>
+      <p:sp>
+        <p:nvSpPr>
+          <p:cNvPr id="31" name="Shape 24"/>
+          <p:cNvSpPr/>
+          <p:nvPr/>
+        </p:nvSpPr>
+        <p:spPr>
+          <a:xfrm>
+            <a:off x="3822192" y="3090672"/>
+            <a:ext cx="2195703" cy="0"/>
+          </a:xfrm>
+          <a:prstGeom prst="line">
+            <a:avLst/>
+          </a:prstGeom>
+          <a:noFill/>
+          <a:ln w="19050">
+            <a:solidFill>
+              <a:srgbClr val="0B2A45"/>
+            </a:solidFill>
+            <a:prstDash val="solid"/>
+          </a:ln>
+        </p:spPr>
+      </p:sp>
+      <p:sp>
+        <p:nvSpPr>
+          <p:cNvPr id="32" name="Text 25"/>
+          <p:cNvSpPr txBox="1"/>
+          <p:nvPr/>
+        </p:nvSpPr>
+        <p:spPr>
+          <a:xfrm>
+            <a:off x="4023360" y="2871216"/>
+            <a:ext cx="822960" cy="192024"/>
+          </a:xfrm>
+          <a:prstGeom prst="rect">
+            <a:avLst/>
+          </a:prstGeom>
+          <a:solidFill>
+            <a:srgbClr val="FFFFFF"/>
+          </a:solidFill>
+          <a:ln/>
+        </p:spPr>
+        <p:txBody>
+          <a:bodyPr wrap="square" lIns="0" tIns="25400" rIns="25400" bIns="0" rtlCol="0" anchor="ctr"/>
+          <a:lstStyle/>
+          <a:p>
+            <a:pPr indent="0" marL="0">
+              <a:buNone/>
+            </a:pPr>
+            <a:r>
+              <a:rPr lang="en-US" sz="900" b="1" dirty="0">
+                <a:solidFill>
+                  <a:srgbClr val="0B2A45"/>
+                </a:solidFill>
+                <a:latin typeface="Open Sans" pitchFamily="34" charset="0"/>
+                <a:ea typeface="Open Sans" pitchFamily="34" charset="-122"/>
+                <a:cs typeface="Open Sans" pitchFamily="34" charset="-120"/>
+              </a:rPr>
+              <a:t>2. Validar</a:t>
+            </a:r>
+            <a:endParaRPr lang="en-US" sz="900" dirty="0"/>
+          </a:p>
+        </p:txBody>
+      </p:sp>
+      <p:sp>
+        <p:nvSpPr>
+          <p:cNvPr id="33" name="Shape 26"/>
+          <p:cNvSpPr/>
+          <p:nvPr/>
+        </p:nvSpPr>
+        <p:spPr>
+          <a:xfrm rot="16200000">
+            <a:off x="3822192" y="3329559"/>
+            <a:ext cx="125730" cy="125730"/>
+          </a:xfrm>
+          <a:prstGeom prst="triangle">
+            <a:avLst/>
+          </a:prstGeom>
+          <a:solidFill>
+            <a:srgbClr val="5A6B7B"/>
+          </a:solidFill>
+          <a:ln/>
+        </p:spPr>
+      </p:sp>
+      <p:sp>
+        <p:nvSpPr>
+          <p:cNvPr id="34" name="Shape 27"/>
+          <p:cNvSpPr/>
+          <p:nvPr/>
+        </p:nvSpPr>
+        <p:spPr>
+          <a:xfrm flipH="1">
+            <a:off x="3885057" y="3392424"/>
+            <a:ext cx="2195703" cy="0"/>
           </a:xfrm>
           <a:prstGeom prst="line">
             <a:avLst/>
@@ -26797,30 +26569,32 @@
       </p:sp>
       <p:sp>
         <p:nvSpPr>
-          <p:cNvPr id="52" name="Text 45"/>
-          <p:cNvSpPr txBox="1"/>
-          <p:nvPr/>
-        </p:nvSpPr>
-        <p:spPr>
-          <a:xfrm>
-            <a:off x="7708392" y="6108192"/>
-            <a:ext cx="914400" cy="228600"/>
-          </a:xfrm>
-          <a:prstGeom prst="rect">
-            <a:avLst/>
-          </a:prstGeom>
-          <a:noFill/>
-          <a:ln/>
-        </p:spPr>
-        <p:txBody>
-          <a:bodyPr wrap="square" lIns="0" tIns="0" rIns="0" bIns="0" rtlCol="0" anchor="ctr"/>
-          <a:lstStyle/>
-          <a:p>
-            <a:pPr indent="0" marL="0">
-              <a:buNone/>
-            </a:pPr>
-            <a:r>
-              <a:rPr lang="en-US" sz="900" dirty="0">
+          <p:cNvPr id="35" name="Text 28"/>
+          <p:cNvSpPr txBox="1"/>
+          <p:nvPr/>
+        </p:nvSpPr>
+        <p:spPr>
+          <a:xfrm>
+            <a:off x="4023360" y="3172968"/>
+            <a:ext cx="950976" cy="192024"/>
+          </a:xfrm>
+          <a:prstGeom prst="rect">
+            <a:avLst/>
+          </a:prstGeom>
+          <a:solidFill>
+            <a:srgbClr val="FFFFFF"/>
+          </a:solidFill>
+          <a:ln/>
+        </p:spPr>
+        <p:txBody>
+          <a:bodyPr wrap="square" lIns="0" tIns="25400" rIns="25400" bIns="0" rtlCol="0" anchor="ctr"/>
+          <a:lstStyle/>
+          <a:p>
+            <a:pPr indent="0" marL="0">
+              <a:buNone/>
+            </a:pPr>
+            <a:r>
+              <a:rPr lang="en-US" sz="900" b="1" dirty="0">
                 <a:solidFill>
                   <a:srgbClr val="5A6B7B"/>
                 </a:solidFill>
@@ -26828,7 +26602,7 @@
                 <a:ea typeface="Open Sans" pitchFamily="34" charset="-122"/>
                 <a:cs typeface="Open Sans" pitchFamily="34" charset="-120"/>
               </a:rPr>
-              <a:t>Respuesta</a:t>
+              <a:t>3. Respuesta</a:t>
             </a:r>
             <a:endParaRPr lang="en-US" sz="900" dirty="0"/>
           </a:p>
@@ -26836,14 +26610,34 @@
       </p:sp>
       <p:sp>
         <p:nvSpPr>
-          <p:cNvPr id="53" name="Shape 46"/>
-          <p:cNvSpPr/>
-          <p:nvPr/>
-        </p:nvSpPr>
-        <p:spPr>
-          <a:xfrm>
-            <a:off x="8686800" y="6217920"/>
-            <a:ext cx="365760" cy="0"/>
+          <p:cNvPr id="36" name="Shape 29"/>
+          <p:cNvSpPr/>
+          <p:nvPr/>
+        </p:nvSpPr>
+        <p:spPr>
+          <a:xfrm rot="5400000">
+            <a:off x="8286750" y="3631311"/>
+            <a:ext cx="125730" cy="125730"/>
+          </a:xfrm>
+          <a:prstGeom prst="triangle">
+            <a:avLst/>
+          </a:prstGeom>
+          <a:solidFill>
+            <a:srgbClr val="E8553F"/>
+          </a:solidFill>
+          <a:ln/>
+        </p:spPr>
+      </p:sp>
+      <p:sp>
+        <p:nvSpPr>
+          <p:cNvPr id="37" name="Shape 30"/>
+          <p:cNvSpPr/>
+          <p:nvPr/>
+        </p:nvSpPr>
+        <p:spPr>
+          <a:xfrm>
+            <a:off x="3822192" y="3694176"/>
+            <a:ext cx="4527423" cy="0"/>
           </a:xfrm>
           <a:prstGeom prst="line">
             <a:avLst/>
@@ -26859,38 +26653,40 @@
       </p:sp>
       <p:sp>
         <p:nvSpPr>
-          <p:cNvPr id="54" name="Text 47"/>
-          <p:cNvSpPr txBox="1"/>
-          <p:nvPr/>
-        </p:nvSpPr>
-        <p:spPr>
-          <a:xfrm>
-            <a:off x="9125712" y="6108192"/>
-            <a:ext cx="914400" cy="228600"/>
-          </a:xfrm>
-          <a:prstGeom prst="rect">
-            <a:avLst/>
-          </a:prstGeom>
-          <a:noFill/>
-          <a:ln/>
-        </p:spPr>
-        <p:txBody>
-          <a:bodyPr wrap="square" lIns="0" tIns="0" rIns="0" bIns="0" rtlCol="0" anchor="ctr"/>
-          <a:lstStyle/>
-          <a:p>
-            <a:pPr indent="0" marL="0">
-              <a:buNone/>
-            </a:pPr>
-            <a:r>
-              <a:rPr lang="en-US" sz="900" dirty="0">
-                <a:solidFill>
-                  <a:srgbClr val="5A6B7B"/>
+          <p:cNvPr id="38" name="Text 31"/>
+          <p:cNvSpPr txBox="1"/>
+          <p:nvPr/>
+        </p:nvSpPr>
+        <p:spPr>
+          <a:xfrm>
+            <a:off x="4023360" y="3474720"/>
+            <a:ext cx="758952" cy="192024"/>
+          </a:xfrm>
+          <a:prstGeom prst="rect">
+            <a:avLst/>
+          </a:prstGeom>
+          <a:solidFill>
+            <a:srgbClr val="FFFFFF"/>
+          </a:solidFill>
+          <a:ln/>
+        </p:spPr>
+        <p:txBody>
+          <a:bodyPr wrap="square" lIns="0" tIns="25400" rIns="25400" bIns="0" rtlCol="0" anchor="ctr"/>
+          <a:lstStyle/>
+          <a:p>
+            <a:pPr indent="0" marL="0">
+              <a:buNone/>
+            </a:pPr>
+            <a:r>
+              <a:rPr lang="en-US" sz="900" b="1" dirty="0">
+                <a:solidFill>
+                  <a:srgbClr val="E8553F"/>
                 </a:solidFill>
                 <a:latin typeface="Open Sans" pitchFamily="34" charset="0"/>
                 <a:ea typeface="Open Sans" pitchFamily="34" charset="-122"/>
                 <a:cs typeface="Open Sans" pitchFamily="34" charset="-120"/>
               </a:rPr>
-              <a:t>Alerta</a:t>
+              <a:t>4. Alerta</a:t>
             </a:r>
             <a:endParaRPr lang="en-US" sz="900" dirty="0"/>
           </a:p>
@@ -26898,14 +26694,370 @@
       </p:sp>
       <p:sp>
         <p:nvSpPr>
-          <p:cNvPr id="55" name="Shape 48"/>
-          <p:cNvSpPr/>
-          <p:nvPr/>
-        </p:nvSpPr>
-        <p:spPr>
-          <a:xfrm>
-            <a:off x="10104120" y="6217920"/>
-            <a:ext cx="365760" cy="0"/>
+          <p:cNvPr id="39" name="Shape 32"/>
+          <p:cNvSpPr/>
+          <p:nvPr/>
+        </p:nvSpPr>
+        <p:spPr>
+          <a:xfrm rot="5400000">
+            <a:off x="10618470" y="3933063"/>
+            <a:ext cx="125730" cy="125730"/>
+          </a:xfrm>
+          <a:prstGeom prst="triangle">
+            <a:avLst/>
+          </a:prstGeom>
+          <a:solidFill>
+            <a:srgbClr val="E8553F"/>
+          </a:solidFill>
+          <a:ln/>
+        </p:spPr>
+      </p:sp>
+      <p:sp>
+        <p:nvSpPr>
+          <p:cNvPr id="40" name="Shape 33"/>
+          <p:cNvSpPr/>
+          <p:nvPr/>
+        </p:nvSpPr>
+        <p:spPr>
+          <a:xfrm>
+            <a:off x="3822192" y="3995928"/>
+            <a:ext cx="6859143" cy="0"/>
+          </a:xfrm>
+          <a:prstGeom prst="line">
+            <a:avLst/>
+          </a:prstGeom>
+          <a:noFill/>
+          <a:ln w="19050">
+            <a:solidFill>
+              <a:srgbClr val="E8553F"/>
+            </a:solidFill>
+            <a:prstDash val="solid"/>
+          </a:ln>
+        </p:spPr>
+      </p:sp>
+      <p:sp>
+        <p:nvSpPr>
+          <p:cNvPr id="41" name="Text 34"/>
+          <p:cNvSpPr txBox="1"/>
+          <p:nvPr/>
+        </p:nvSpPr>
+        <p:spPr>
+          <a:xfrm>
+            <a:off x="4023360" y="3776472"/>
+            <a:ext cx="758952" cy="192024"/>
+          </a:xfrm>
+          <a:prstGeom prst="rect">
+            <a:avLst/>
+          </a:prstGeom>
+          <a:solidFill>
+            <a:srgbClr val="FFFFFF"/>
+          </a:solidFill>
+          <a:ln/>
+        </p:spPr>
+        <p:txBody>
+          <a:bodyPr wrap="square" lIns="0" tIns="25400" rIns="25400" bIns="0" rtlCol="0" anchor="ctr"/>
+          <a:lstStyle/>
+          <a:p>
+            <a:pPr indent="0" marL="0">
+              <a:buNone/>
+            </a:pPr>
+            <a:r>
+              <a:rPr lang="en-US" sz="900" b="1" dirty="0">
+                <a:solidFill>
+                  <a:srgbClr val="E8553F"/>
+                </a:solidFill>
+                <a:latin typeface="Open Sans" pitchFamily="34" charset="0"/>
+                <a:ea typeface="Open Sans" pitchFamily="34" charset="-122"/>
+                <a:cs typeface="Open Sans" pitchFamily="34" charset="-120"/>
+              </a:rPr>
+              <a:t>5. Alerta</a:t>
+            </a:r>
+            <a:endParaRPr lang="en-US" sz="900" dirty="0"/>
+          </a:p>
+        </p:txBody>
+      </p:sp>
+      <p:sp>
+        <p:nvSpPr>
+          <p:cNvPr id="42" name="Shape 35"/>
+          <p:cNvSpPr/>
+          <p:nvPr/>
+        </p:nvSpPr>
+        <p:spPr>
+          <a:xfrm rot="5400000">
+            <a:off x="3550158" y="4234815"/>
+            <a:ext cx="125730" cy="125730"/>
+          </a:xfrm>
+          <a:prstGeom prst="triangle">
+            <a:avLst/>
+          </a:prstGeom>
+          <a:solidFill>
+            <a:srgbClr val="0B2A45"/>
+          </a:solidFill>
+          <a:ln/>
+        </p:spPr>
+      </p:sp>
+      <p:sp>
+        <p:nvSpPr>
+          <p:cNvPr id="43" name="Shape 36"/>
+          <p:cNvSpPr/>
+          <p:nvPr/>
+        </p:nvSpPr>
+        <p:spPr>
+          <a:xfrm>
+            <a:off x="1417320" y="4297680"/>
+            <a:ext cx="2195703" cy="0"/>
+          </a:xfrm>
+          <a:prstGeom prst="line">
+            <a:avLst/>
+          </a:prstGeom>
+          <a:noFill/>
+          <a:ln w="19050">
+            <a:solidFill>
+              <a:srgbClr val="0B2A45"/>
+            </a:solidFill>
+            <a:prstDash val="solid"/>
+          </a:ln>
+        </p:spPr>
+      </p:sp>
+      <p:sp>
+        <p:nvSpPr>
+          <p:cNvPr id="44" name="Text 37"/>
+          <p:cNvSpPr txBox="1"/>
+          <p:nvPr/>
+        </p:nvSpPr>
+        <p:spPr>
+          <a:xfrm>
+            <a:off x="1618488" y="4078224"/>
+            <a:ext cx="1335024" cy="192024"/>
+          </a:xfrm>
+          <a:prstGeom prst="rect">
+            <a:avLst/>
+          </a:prstGeom>
+          <a:solidFill>
+            <a:srgbClr val="FFFFFF"/>
+          </a:solidFill>
+          <a:ln/>
+        </p:spPr>
+        <p:txBody>
+          <a:bodyPr wrap="square" lIns="0" tIns="25400" rIns="25400" bIns="0" rtlCol="0" anchor="ctr"/>
+          <a:lstStyle/>
+          <a:p>
+            <a:pPr indent="0" marL="0">
+              <a:buNone/>
+            </a:pPr>
+            <a:r>
+              <a:rPr lang="en-US" sz="900" b="1" dirty="0">
+                <a:solidFill>
+                  <a:srgbClr val="0B2A45"/>
+                </a:solidFill>
+                <a:latin typeface="Open Sans" pitchFamily="34" charset="0"/>
+                <a:ea typeface="Open Sans" pitchFamily="34" charset="-122"/>
+                <a:cs typeface="Open Sans" pitchFamily="34" charset="-120"/>
+              </a:rPr>
+              <a:t>6. Bitácora, fotos</a:t>
+            </a:r>
+            <a:endParaRPr lang="en-US" sz="900" dirty="0"/>
+          </a:p>
+        </p:txBody>
+      </p:sp>
+      <p:sp>
+        <p:nvSpPr>
+          <p:cNvPr id="45" name="Shape 38"/>
+          <p:cNvSpPr/>
+          <p:nvPr/>
+        </p:nvSpPr>
+        <p:spPr>
+          <a:xfrm rot="16200000">
+            <a:off x="3822192" y="4536567"/>
+            <a:ext cx="125730" cy="125730"/>
+          </a:xfrm>
+          <a:prstGeom prst="triangle">
+            <a:avLst/>
+          </a:prstGeom>
+          <a:solidFill>
+            <a:srgbClr val="5A6B7B"/>
+          </a:solidFill>
+          <a:ln/>
+        </p:spPr>
+      </p:sp>
+      <p:sp>
+        <p:nvSpPr>
+          <p:cNvPr id="46" name="Shape 39"/>
+          <p:cNvSpPr/>
+          <p:nvPr/>
+        </p:nvSpPr>
+        <p:spPr>
+          <a:xfrm flipH="1">
+            <a:off x="3885057" y="4599432"/>
+            <a:ext cx="2195703" cy="0"/>
+          </a:xfrm>
+          <a:prstGeom prst="line">
+            <a:avLst/>
+          </a:prstGeom>
+          <a:noFill/>
+          <a:ln w="19050">
+            <a:solidFill>
+              <a:srgbClr val="5A6B7B"/>
+            </a:solidFill>
+            <a:prstDash val="dash"/>
+          </a:ln>
+        </p:spPr>
+      </p:sp>
+      <p:sp>
+        <p:nvSpPr>
+          <p:cNvPr id="47" name="Text 40"/>
+          <p:cNvSpPr txBox="1"/>
+          <p:nvPr/>
+        </p:nvSpPr>
+        <p:spPr>
+          <a:xfrm>
+            <a:off x="4023360" y="4379976"/>
+            <a:ext cx="1143000" cy="192024"/>
+          </a:xfrm>
+          <a:prstGeom prst="rect">
+            <a:avLst/>
+          </a:prstGeom>
+          <a:solidFill>
+            <a:srgbClr val="FFFFFF"/>
+          </a:solidFill>
+          <a:ln/>
+        </p:spPr>
+        <p:txBody>
+          <a:bodyPr wrap="square" lIns="0" tIns="25400" rIns="25400" bIns="0" rtlCol="0" anchor="ctr"/>
+          <a:lstStyle/>
+          <a:p>
+            <a:pPr indent="0" marL="0">
+              <a:buNone/>
+            </a:pPr>
+            <a:r>
+              <a:rPr lang="en-US" sz="900" b="1" dirty="0">
+                <a:solidFill>
+                  <a:srgbClr val="5A6B7B"/>
+                </a:solidFill>
+                <a:latin typeface="Open Sans" pitchFamily="34" charset="0"/>
+                <a:ea typeface="Open Sans" pitchFamily="34" charset="-122"/>
+                <a:cs typeface="Open Sans" pitchFamily="34" charset="-120"/>
+              </a:rPr>
+              <a:t>7. Confirmación</a:t>
+            </a:r>
+            <a:endParaRPr lang="en-US" sz="900" dirty="0"/>
+          </a:p>
+        </p:txBody>
+      </p:sp>
+      <p:sp>
+        <p:nvSpPr>
+          <p:cNvPr id="48" name="Shape 41"/>
+          <p:cNvSpPr/>
+          <p:nvPr/>
+        </p:nvSpPr>
+        <p:spPr>
+          <a:xfrm rot="5400000">
+            <a:off x="5955030" y="4838319"/>
+            <a:ext cx="125730" cy="125730"/>
+          </a:xfrm>
+          <a:prstGeom prst="triangle">
+            <a:avLst/>
+          </a:prstGeom>
+          <a:solidFill>
+            <a:srgbClr val="0B2A45"/>
+          </a:solidFill>
+          <a:ln/>
+        </p:spPr>
+      </p:sp>
+      <p:sp>
+        <p:nvSpPr>
+          <p:cNvPr id="49" name="Shape 42"/>
+          <p:cNvSpPr/>
+          <p:nvPr/>
+        </p:nvSpPr>
+        <p:spPr>
+          <a:xfrm>
+            <a:off x="3822192" y="4901184"/>
+            <a:ext cx="2195703" cy="0"/>
+          </a:xfrm>
+          <a:prstGeom prst="line">
+            <a:avLst/>
+          </a:prstGeom>
+          <a:noFill/>
+          <a:ln w="19050">
+            <a:solidFill>
+              <a:srgbClr val="0B2A45"/>
+            </a:solidFill>
+            <a:prstDash val="solid"/>
+          </a:ln>
+        </p:spPr>
+      </p:sp>
+      <p:sp>
+        <p:nvSpPr>
+          <p:cNvPr id="50" name="Text 43"/>
+          <p:cNvSpPr txBox="1"/>
+          <p:nvPr/>
+        </p:nvSpPr>
+        <p:spPr>
+          <a:xfrm>
+            <a:off x="4023360" y="4681728"/>
+            <a:ext cx="1078992" cy="192024"/>
+          </a:xfrm>
+          <a:prstGeom prst="rect">
+            <a:avLst/>
+          </a:prstGeom>
+          <a:solidFill>
+            <a:srgbClr val="FFFFFF"/>
+          </a:solidFill>
+          <a:ln/>
+        </p:spPr>
+        <p:txBody>
+          <a:bodyPr wrap="square" lIns="0" tIns="25400" rIns="25400" bIns="0" rtlCol="0" anchor="ctr"/>
+          <a:lstStyle/>
+          <a:p>
+            <a:pPr indent="0" marL="0">
+              <a:buNone/>
+            </a:pPr>
+            <a:r>
+              <a:rPr lang="en-US" sz="900" b="1" dirty="0">
+                <a:solidFill>
+                  <a:srgbClr val="0B2A45"/>
+                </a:solidFill>
+                <a:latin typeface="Open Sans" pitchFamily="34" charset="0"/>
+                <a:ea typeface="Open Sans" pitchFamily="34" charset="-122"/>
+                <a:cs typeface="Open Sans" pitchFamily="34" charset="-120"/>
+              </a:rPr>
+              <a:t>8. QR generado</a:t>
+            </a:r>
+            <a:endParaRPr lang="en-US" sz="900" dirty="0"/>
+          </a:p>
+        </p:txBody>
+      </p:sp>
+      <p:sp>
+        <p:nvSpPr>
+          <p:cNvPr id="51" name="Shape 44"/>
+          <p:cNvSpPr/>
+          <p:nvPr/>
+        </p:nvSpPr>
+        <p:spPr>
+          <a:xfrm rot="5400000">
+            <a:off x="8286750" y="5140071"/>
+            <a:ext cx="125730" cy="125730"/>
+          </a:xfrm>
+          <a:prstGeom prst="triangle">
+            <a:avLst/>
+          </a:prstGeom>
+          <a:solidFill>
+            <a:srgbClr val="0E7C86"/>
+          </a:solidFill>
+          <a:ln/>
+        </p:spPr>
+      </p:sp>
+      <p:sp>
+        <p:nvSpPr>
+          <p:cNvPr id="52" name="Shape 45"/>
+          <p:cNvSpPr/>
+          <p:nvPr/>
+        </p:nvSpPr>
+        <p:spPr>
+          <a:xfrm>
+            <a:off x="3822192" y="5202936"/>
+            <a:ext cx="4527423" cy="0"/>
           </a:xfrm>
           <a:prstGeom prst="line">
             <a:avLst/>
@@ -26921,37 +27073,455 @@
       </p:sp>
       <p:sp>
         <p:nvSpPr>
-          <p:cNvPr id="56" name="Text 49"/>
-          <p:cNvSpPr txBox="1"/>
-          <p:nvPr/>
-        </p:nvSpPr>
-        <p:spPr>
-          <a:xfrm>
-            <a:off x="10543032" y="6108192"/>
-            <a:ext cx="914400" cy="228600"/>
-          </a:xfrm>
-          <a:prstGeom prst="rect">
-            <a:avLst/>
-          </a:prstGeom>
-          <a:noFill/>
-          <a:ln/>
-        </p:spPr>
-        <p:txBody>
-          <a:bodyPr wrap="square" lIns="0" tIns="0" rIns="0" bIns="0" rtlCol="0" anchor="ctr"/>
-          <a:lstStyle/>
-          <a:p>
-            <a:pPr indent="0" marL="0">
-              <a:buNone/>
-            </a:pPr>
-            <a:r>
-              <a:rPr lang="en-US" sz="900" dirty="0">
-                <a:solidFill>
-                  <a:srgbClr val="5A6B7B"/>
+          <p:cNvPr id="53" name="Text 46"/>
+          <p:cNvSpPr txBox="1"/>
+          <p:nvPr/>
+        </p:nvSpPr>
+        <p:spPr>
+          <a:xfrm>
+            <a:off x="4023360" y="4983480"/>
+            <a:ext cx="822960" cy="192024"/>
+          </a:xfrm>
+          <a:prstGeom prst="rect">
+            <a:avLst/>
+          </a:prstGeom>
+          <a:solidFill>
+            <a:srgbClr val="FFFFFF"/>
+          </a:solidFill>
+          <a:ln/>
+        </p:spPr>
+        <p:txBody>
+          <a:bodyPr wrap="square" lIns="0" tIns="25400" rIns="25400" bIns="0" rtlCol="0" anchor="ctr"/>
+          <a:lstStyle/>
+          <a:p>
+            <a:pPr indent="0" marL="0">
+              <a:buNone/>
+            </a:pPr>
+            <a:r>
+              <a:rPr lang="en-US" sz="900" b="1" dirty="0">
+                <a:solidFill>
+                  <a:srgbClr val="0E7C86"/>
                 </a:solidFill>
                 <a:latin typeface="Open Sans" pitchFamily="34" charset="0"/>
                 <a:ea typeface="Open Sans" pitchFamily="34" charset="-122"/>
                 <a:cs typeface="Open Sans" pitchFamily="34" charset="-120"/>
               </a:rPr>
+              <a:t>9. Reporte</a:t>
+            </a:r>
+            <a:endParaRPr lang="en-US" sz="900" dirty="0"/>
+          </a:p>
+        </p:txBody>
+      </p:sp>
+      <p:sp>
+        <p:nvSpPr>
+          <p:cNvPr id="54" name="Shape 47"/>
+          <p:cNvSpPr/>
+          <p:nvPr/>
+        </p:nvSpPr>
+        <p:spPr>
+          <a:xfrm rot="5400000">
+            <a:off x="10618470" y="5441823"/>
+            <a:ext cx="125730" cy="125730"/>
+          </a:xfrm>
+          <a:prstGeom prst="triangle">
+            <a:avLst/>
+          </a:prstGeom>
+          <a:solidFill>
+            <a:srgbClr val="0E7C86"/>
+          </a:solidFill>
+          <a:ln/>
+        </p:spPr>
+      </p:sp>
+      <p:sp>
+        <p:nvSpPr>
+          <p:cNvPr id="55" name="Shape 48"/>
+          <p:cNvSpPr/>
+          <p:nvPr/>
+        </p:nvSpPr>
+        <p:spPr>
+          <a:xfrm>
+            <a:off x="3822192" y="5504688"/>
+            <a:ext cx="6859143" cy="0"/>
+          </a:xfrm>
+          <a:prstGeom prst="line">
+            <a:avLst/>
+          </a:prstGeom>
+          <a:noFill/>
+          <a:ln w="19050">
+            <a:solidFill>
+              <a:srgbClr val="0E7C86"/>
+            </a:solidFill>
+            <a:prstDash val="solid"/>
+          </a:ln>
+        </p:spPr>
+      </p:sp>
+      <p:sp>
+        <p:nvSpPr>
+          <p:cNvPr id="56" name="Text 49"/>
+          <p:cNvSpPr txBox="1"/>
+          <p:nvPr/>
+        </p:nvSpPr>
+        <p:spPr>
+          <a:xfrm>
+            <a:off x="4023360" y="5285232"/>
+            <a:ext cx="886968" cy="192024"/>
+          </a:xfrm>
+          <a:prstGeom prst="rect">
+            <a:avLst/>
+          </a:prstGeom>
+          <a:solidFill>
+            <a:srgbClr val="FFFFFF"/>
+          </a:solidFill>
+          <a:ln/>
+        </p:spPr>
+        <p:txBody>
+          <a:bodyPr wrap="square" lIns="0" tIns="25400" rIns="25400" bIns="0" rtlCol="0" anchor="ctr"/>
+          <a:lstStyle/>
+          <a:p>
+            <a:pPr indent="0" marL="0">
+              <a:buNone/>
+            </a:pPr>
+            <a:r>
+              <a:rPr lang="en-US" sz="900" b="1" dirty="0">
+                <a:solidFill>
+                  <a:srgbClr val="0E7C86"/>
+                </a:solidFill>
+                <a:latin typeface="Open Sans" pitchFamily="34" charset="0"/>
+                <a:ea typeface="Open Sans" pitchFamily="34" charset="-122"/>
+                <a:cs typeface="Open Sans" pitchFamily="34" charset="-120"/>
+              </a:rPr>
+              <a:t>10. Reporte</a:t>
+            </a:r>
+            <a:endParaRPr lang="en-US" sz="900" dirty="0"/>
+          </a:p>
+        </p:txBody>
+      </p:sp>
+      <p:sp>
+        <p:nvSpPr>
+          <p:cNvPr id="57" name="Shape 50"/>
+          <p:cNvSpPr/>
+          <p:nvPr/>
+        </p:nvSpPr>
+        <p:spPr>
+          <a:xfrm rot="16200000">
+            <a:off x="1417320" y="5743575"/>
+            <a:ext cx="125730" cy="125730"/>
+          </a:xfrm>
+          <a:prstGeom prst="triangle">
+            <a:avLst/>
+          </a:prstGeom>
+          <a:solidFill>
+            <a:srgbClr val="0B2A45"/>
+          </a:solidFill>
+          <a:ln/>
+        </p:spPr>
+      </p:sp>
+      <p:sp>
+        <p:nvSpPr>
+          <p:cNvPr id="58" name="Shape 51"/>
+          <p:cNvSpPr/>
+          <p:nvPr/>
+        </p:nvSpPr>
+        <p:spPr>
+          <a:xfrm flipH="1">
+            <a:off x="1480185" y="5806440"/>
+            <a:ext cx="2195703" cy="0"/>
+          </a:xfrm>
+          <a:prstGeom prst="line">
+            <a:avLst/>
+          </a:prstGeom>
+          <a:noFill/>
+          <a:ln w="19050">
+            <a:solidFill>
+              <a:srgbClr val="0B2A45"/>
+            </a:solidFill>
+            <a:prstDash val="solid"/>
+          </a:ln>
+        </p:spPr>
+      </p:sp>
+      <p:sp>
+        <p:nvSpPr>
+          <p:cNvPr id="59" name="Text 52"/>
+          <p:cNvSpPr txBox="1"/>
+          <p:nvPr/>
+        </p:nvSpPr>
+        <p:spPr>
+          <a:xfrm>
+            <a:off x="1618488" y="5586984"/>
+            <a:ext cx="1207008" cy="192024"/>
+          </a:xfrm>
+          <a:prstGeom prst="rect">
+            <a:avLst/>
+          </a:prstGeom>
+          <a:solidFill>
+            <a:srgbClr val="FFFFFF"/>
+          </a:solidFill>
+          <a:ln/>
+        </p:spPr>
+        <p:txBody>
+          <a:bodyPr wrap="square" lIns="0" tIns="25400" rIns="25400" bIns="0" rtlCol="0" anchor="ctr"/>
+          <a:lstStyle/>
+          <a:p>
+            <a:pPr indent="0" marL="0">
+              <a:buNone/>
+            </a:pPr>
+            <a:r>
+              <a:rPr lang="en-US" sz="900" b="1" dirty="0">
+                <a:solidFill>
+                  <a:srgbClr val="0B2A45"/>
+                </a:solidFill>
+                <a:latin typeface="Open Sans" pitchFamily="34" charset="0"/>
+                <a:ea typeface="Open Sans" pitchFamily="34" charset="-122"/>
+                <a:cs typeface="Open Sans" pitchFamily="34" charset="-120"/>
+              </a:rPr>
+              <a:t>11. Notificación</a:t>
+            </a:r>
+            <a:endParaRPr lang="en-US" sz="900" dirty="0"/>
+          </a:p>
+        </p:txBody>
+      </p:sp>
+      <p:sp>
+        <p:nvSpPr>
+          <p:cNvPr id="60" name="Shape 53"/>
+          <p:cNvSpPr/>
+          <p:nvPr/>
+        </p:nvSpPr>
+        <p:spPr>
+          <a:xfrm>
+            <a:off x="5852160" y="6217920"/>
+            <a:ext cx="365760" cy="0"/>
+          </a:xfrm>
+          <a:prstGeom prst="line">
+            <a:avLst/>
+          </a:prstGeom>
+          <a:noFill/>
+          <a:ln w="19050">
+            <a:solidFill>
+              <a:srgbClr val="0B2A45"/>
+            </a:solidFill>
+            <a:prstDash val="solid"/>
+          </a:ln>
+        </p:spPr>
+      </p:sp>
+      <p:sp>
+        <p:nvSpPr>
+          <p:cNvPr id="61" name="Text 54"/>
+          <p:cNvSpPr txBox="1"/>
+          <p:nvPr/>
+        </p:nvSpPr>
+        <p:spPr>
+          <a:xfrm>
+            <a:off x="6291072" y="6108192"/>
+            <a:ext cx="914400" cy="228600"/>
+          </a:xfrm>
+          <a:prstGeom prst="rect">
+            <a:avLst/>
+          </a:prstGeom>
+          <a:noFill/>
+          <a:ln/>
+        </p:spPr>
+        <p:txBody>
+          <a:bodyPr wrap="square" lIns="0" tIns="0" rIns="0" bIns="0" rtlCol="0" anchor="ctr"/>
+          <a:lstStyle/>
+          <a:p>
+            <a:pPr indent="0" marL="0">
+              <a:buNone/>
+            </a:pPr>
+            <a:r>
+              <a:rPr lang="en-US" sz="900" dirty="0">
+                <a:solidFill>
+                  <a:srgbClr val="5A6B7B"/>
+                </a:solidFill>
+                <a:latin typeface="Open Sans" pitchFamily="34" charset="0"/>
+                <a:ea typeface="Open Sans" pitchFamily="34" charset="-122"/>
+                <a:cs typeface="Open Sans" pitchFamily="34" charset="-120"/>
+              </a:rPr>
+              <a:t>Llamada</a:t>
+            </a:r>
+            <a:endParaRPr lang="en-US" sz="900" dirty="0"/>
+          </a:p>
+        </p:txBody>
+      </p:sp>
+      <p:sp>
+        <p:nvSpPr>
+          <p:cNvPr id="62" name="Shape 55"/>
+          <p:cNvSpPr/>
+          <p:nvPr/>
+        </p:nvSpPr>
+        <p:spPr>
+          <a:xfrm>
+            <a:off x="7269480" y="6217920"/>
+            <a:ext cx="365760" cy="0"/>
+          </a:xfrm>
+          <a:prstGeom prst="line">
+            <a:avLst/>
+          </a:prstGeom>
+          <a:noFill/>
+          <a:ln w="19050">
+            <a:solidFill>
+              <a:srgbClr val="5A6B7B"/>
+            </a:solidFill>
+            <a:prstDash val="dash"/>
+          </a:ln>
+        </p:spPr>
+      </p:sp>
+      <p:sp>
+        <p:nvSpPr>
+          <p:cNvPr id="63" name="Text 56"/>
+          <p:cNvSpPr txBox="1"/>
+          <p:nvPr/>
+        </p:nvSpPr>
+        <p:spPr>
+          <a:xfrm>
+            <a:off x="7708392" y="6108192"/>
+            <a:ext cx="914400" cy="228600"/>
+          </a:xfrm>
+          <a:prstGeom prst="rect">
+            <a:avLst/>
+          </a:prstGeom>
+          <a:noFill/>
+          <a:ln/>
+        </p:spPr>
+        <p:txBody>
+          <a:bodyPr wrap="square" lIns="0" tIns="0" rIns="0" bIns="0" rtlCol="0" anchor="ctr"/>
+          <a:lstStyle/>
+          <a:p>
+            <a:pPr indent="0" marL="0">
+              <a:buNone/>
+            </a:pPr>
+            <a:r>
+              <a:rPr lang="en-US" sz="900" dirty="0">
+                <a:solidFill>
+                  <a:srgbClr val="5A6B7B"/>
+                </a:solidFill>
+                <a:latin typeface="Open Sans" pitchFamily="34" charset="0"/>
+                <a:ea typeface="Open Sans" pitchFamily="34" charset="-122"/>
+                <a:cs typeface="Open Sans" pitchFamily="34" charset="-120"/>
+              </a:rPr>
+              <a:t>Respuesta</a:t>
+            </a:r>
+            <a:endParaRPr lang="en-US" sz="900" dirty="0"/>
+          </a:p>
+        </p:txBody>
+      </p:sp>
+      <p:sp>
+        <p:nvSpPr>
+          <p:cNvPr id="64" name="Shape 57"/>
+          <p:cNvSpPr/>
+          <p:nvPr/>
+        </p:nvSpPr>
+        <p:spPr>
+          <a:xfrm>
+            <a:off x="8686800" y="6217920"/>
+            <a:ext cx="365760" cy="0"/>
+          </a:xfrm>
+          <a:prstGeom prst="line">
+            <a:avLst/>
+          </a:prstGeom>
+          <a:noFill/>
+          <a:ln w="19050">
+            <a:solidFill>
+              <a:srgbClr val="E8553F"/>
+            </a:solidFill>
+            <a:prstDash val="solid"/>
+          </a:ln>
+        </p:spPr>
+      </p:sp>
+      <p:sp>
+        <p:nvSpPr>
+          <p:cNvPr id="65" name="Text 58"/>
+          <p:cNvSpPr txBox="1"/>
+          <p:nvPr/>
+        </p:nvSpPr>
+        <p:spPr>
+          <a:xfrm>
+            <a:off x="9125712" y="6108192"/>
+            <a:ext cx="914400" cy="228600"/>
+          </a:xfrm>
+          <a:prstGeom prst="rect">
+            <a:avLst/>
+          </a:prstGeom>
+          <a:noFill/>
+          <a:ln/>
+        </p:spPr>
+        <p:txBody>
+          <a:bodyPr wrap="square" lIns="0" tIns="0" rIns="0" bIns="0" rtlCol="0" anchor="ctr"/>
+          <a:lstStyle/>
+          <a:p>
+            <a:pPr indent="0" marL="0">
+              <a:buNone/>
+            </a:pPr>
+            <a:r>
+              <a:rPr lang="en-US" sz="900" dirty="0">
+                <a:solidFill>
+                  <a:srgbClr val="5A6B7B"/>
+                </a:solidFill>
+                <a:latin typeface="Open Sans" pitchFamily="34" charset="0"/>
+                <a:ea typeface="Open Sans" pitchFamily="34" charset="-122"/>
+                <a:cs typeface="Open Sans" pitchFamily="34" charset="-120"/>
+              </a:rPr>
+              <a:t>Alerta</a:t>
+            </a:r>
+            <a:endParaRPr lang="en-US" sz="900" dirty="0"/>
+          </a:p>
+        </p:txBody>
+      </p:sp>
+      <p:sp>
+        <p:nvSpPr>
+          <p:cNvPr id="66" name="Shape 59"/>
+          <p:cNvSpPr/>
+          <p:nvPr/>
+        </p:nvSpPr>
+        <p:spPr>
+          <a:xfrm>
+            <a:off x="10104120" y="6217920"/>
+            <a:ext cx="365760" cy="0"/>
+          </a:xfrm>
+          <a:prstGeom prst="line">
+            <a:avLst/>
+          </a:prstGeom>
+          <a:noFill/>
+          <a:ln w="19050">
+            <a:solidFill>
+              <a:srgbClr val="0E7C86"/>
+            </a:solidFill>
+            <a:prstDash val="solid"/>
+          </a:ln>
+        </p:spPr>
+      </p:sp>
+      <p:sp>
+        <p:nvSpPr>
+          <p:cNvPr id="67" name="Text 60"/>
+          <p:cNvSpPr txBox="1"/>
+          <p:nvPr/>
+        </p:nvSpPr>
+        <p:spPr>
+          <a:xfrm>
+            <a:off x="10543032" y="6108192"/>
+            <a:ext cx="914400" cy="228600"/>
+          </a:xfrm>
+          <a:prstGeom prst="rect">
+            <a:avLst/>
+          </a:prstGeom>
+          <a:noFill/>
+          <a:ln/>
+        </p:spPr>
+        <p:txBody>
+          <a:bodyPr wrap="square" lIns="0" tIns="0" rIns="0" bIns="0" rtlCol="0" anchor="ctr"/>
+          <a:lstStyle/>
+          <a:p>
+            <a:pPr indent="0" marL="0">
+              <a:buNone/>
+            </a:pPr>
+            <a:r>
+              <a:rPr lang="en-US" sz="900" dirty="0">
+                <a:solidFill>
+                  <a:srgbClr val="5A6B7B"/>
+                </a:solidFill>
+                <a:latin typeface="Open Sans" pitchFamily="34" charset="0"/>
+                <a:ea typeface="Open Sans" pitchFamily="34" charset="-122"/>
+                <a:cs typeface="Open Sans" pitchFamily="34" charset="-120"/>
+              </a:rPr>
               <a:t>Reporte</a:t>
             </a:r>
             <a:endParaRPr lang="en-US" sz="900" dirty="0"/>
@@ -26960,7 +27530,7 @@
       </p:sp>
       <p:sp>
         <p:nvSpPr>
-          <p:cNvPr id="57" name="Text 50"/>
+          <p:cNvPr id="68" name="Text 61"/>
           <p:cNvSpPr txBox="1"/>
           <p:nvPr/>
         </p:nvSpPr>
@@ -26999,7 +27569,7 @@
       </p:sp>
       <p:sp>
         <p:nvSpPr>
-          <p:cNvPr id="58" name="Text 51"/>
+          <p:cNvPr id="69" name="Text 62"/>
           <p:cNvSpPr txBox="1"/>
           <p:nvPr/>
         </p:nvSpPr>
@@ -27650,9 +28220,29 @@
           <p:nvPr/>
         </p:nvSpPr>
         <p:spPr>
+          <a:xfrm rot="5400000">
+            <a:off x="3995928" y="3680460"/>
+            <a:ext cx="137160" cy="137160"/>
+          </a:xfrm>
+          <a:prstGeom prst="triangle">
+            <a:avLst/>
+          </a:prstGeom>
+          <a:solidFill>
+            <a:srgbClr val="0F4C6B"/>
+          </a:solidFill>
+          <a:ln/>
+        </p:spPr>
+      </p:sp>
+      <p:sp>
+        <p:nvSpPr>
+          <p:cNvPr id="20" name="Shape 17"/>
+          <p:cNvSpPr/>
+          <p:nvPr/>
+        </p:nvSpPr>
+        <p:spPr>
           <a:xfrm>
             <a:off x="2414016" y="3749040"/>
-            <a:ext cx="1719072" cy="0"/>
+            <a:ext cx="1650492" cy="0"/>
           </a:xfrm>
           <a:prstGeom prst="line">
             <a:avLst/>
@@ -27663,13 +28253,12 @@
               <a:srgbClr val="0F4C6B"/>
             </a:solidFill>
             <a:prstDash val="solid"/>
-            <a:tailEnd type="triangle"/>
           </a:ln>
         </p:spPr>
       </p:sp>
       <p:sp>
         <p:nvSpPr>
-          <p:cNvPr id="20" name="Shape 17"/>
+          <p:cNvPr id="21" name="Shape 18"/>
           <p:cNvSpPr/>
           <p:nvPr/>
         </p:nvSpPr>
@@ -27696,7 +28285,7 @@
       </p:sp>
       <p:pic>
         <p:nvPicPr>
-          <p:cNvPr id="21" name="Image 1" descr="preencoded.png">    </p:cNvPr>
+          <p:cNvPr id="22" name="Image 1" descr="preencoded.png">    </p:cNvPr>
           <p:cNvPicPr>
             <a:picLocks noChangeAspect="1"/>
           </p:cNvPicPr>
@@ -27720,7 +28309,7 @@
       </p:pic>
       <p:sp>
         <p:nvSpPr>
-          <p:cNvPr id="22" name="Text 18"/>
+          <p:cNvPr id="23" name="Text 19"/>
           <p:cNvSpPr txBox="1"/>
           <p:nvPr/>
         </p:nvSpPr>
@@ -27759,7 +28348,7 @@
       </p:sp>
       <p:sp>
         <p:nvSpPr>
-          <p:cNvPr id="23" name="Text 19"/>
+          <p:cNvPr id="24" name="Text 20"/>
           <p:cNvSpPr txBox="1"/>
           <p:nvPr/>
         </p:nvSpPr>
@@ -27798,14 +28387,34 @@
       </p:sp>
       <p:sp>
         <p:nvSpPr>
-          <p:cNvPr id="24" name="Shape 20"/>
+          <p:cNvPr id="25" name="Shape 21"/>
+          <p:cNvSpPr/>
+          <p:nvPr/>
+        </p:nvSpPr>
+        <p:spPr>
+          <a:xfrm rot="5400000">
+            <a:off x="6812280" y="3680460"/>
+            <a:ext cx="137160" cy="137160"/>
+          </a:xfrm>
+          <a:prstGeom prst="triangle">
+            <a:avLst/>
+          </a:prstGeom>
+          <a:solidFill>
+            <a:srgbClr val="0F4C6B"/>
+          </a:solidFill>
+          <a:ln/>
+        </p:spPr>
+      </p:sp>
+      <p:sp>
+        <p:nvSpPr>
+          <p:cNvPr id="26" name="Shape 22"/>
           <p:cNvSpPr/>
           <p:nvPr/>
         </p:nvSpPr>
         <p:spPr>
           <a:xfrm>
             <a:off x="5230368" y="3749040"/>
-            <a:ext cx="1719072" cy="0"/>
+            <a:ext cx="1650492" cy="0"/>
           </a:xfrm>
           <a:prstGeom prst="line">
             <a:avLst/>
@@ -27816,13 +28425,12 @@
               <a:srgbClr val="0F4C6B"/>
             </a:solidFill>
             <a:prstDash val="solid"/>
-            <a:tailEnd type="triangle"/>
           </a:ln>
         </p:spPr>
       </p:sp>
       <p:sp>
         <p:nvSpPr>
-          <p:cNvPr id="25" name="Shape 21"/>
+          <p:cNvPr id="27" name="Shape 23"/>
           <p:cNvSpPr/>
           <p:nvPr/>
         </p:nvSpPr>
@@ -27849,7 +28457,7 @@
       </p:sp>
       <p:pic>
         <p:nvPicPr>
-          <p:cNvPr id="26" name="Image 2" descr="preencoded.png">    </p:cNvPr>
+          <p:cNvPr id="28" name="Image 2" descr="preencoded.png">    </p:cNvPr>
           <p:cNvPicPr>
             <a:picLocks noChangeAspect="1"/>
           </p:cNvPicPr>
@@ -27873,7 +28481,7 @@
       </p:pic>
       <p:sp>
         <p:nvSpPr>
-          <p:cNvPr id="27" name="Text 22"/>
+          <p:cNvPr id="29" name="Text 24"/>
           <p:cNvSpPr txBox="1"/>
           <p:nvPr/>
         </p:nvSpPr>
@@ -27912,7 +28520,7 @@
       </p:sp>
       <p:sp>
         <p:nvSpPr>
-          <p:cNvPr id="28" name="Text 23"/>
+          <p:cNvPr id="30" name="Text 25"/>
           <p:cNvSpPr txBox="1"/>
           <p:nvPr/>
         </p:nvSpPr>
@@ -27951,14 +28559,34 @@
       </p:sp>
       <p:sp>
         <p:nvSpPr>
-          <p:cNvPr id="29" name="Shape 24"/>
+          <p:cNvPr id="31" name="Shape 26"/>
+          <p:cNvSpPr/>
+          <p:nvPr/>
+        </p:nvSpPr>
+        <p:spPr>
+          <a:xfrm rot="5400000">
+            <a:off x="9628632" y="3680460"/>
+            <a:ext cx="137160" cy="137160"/>
+          </a:xfrm>
+          <a:prstGeom prst="triangle">
+            <a:avLst/>
+          </a:prstGeom>
+          <a:solidFill>
+            <a:srgbClr val="0F4C6B"/>
+          </a:solidFill>
+          <a:ln/>
+        </p:spPr>
+      </p:sp>
+      <p:sp>
+        <p:nvSpPr>
+          <p:cNvPr id="32" name="Shape 27"/>
           <p:cNvSpPr/>
           <p:nvPr/>
         </p:nvSpPr>
         <p:spPr>
           <a:xfrm>
             <a:off x="8046720" y="3749040"/>
-            <a:ext cx="1719072" cy="0"/>
+            <a:ext cx="1650492" cy="0"/>
           </a:xfrm>
           <a:prstGeom prst="line">
             <a:avLst/>
@@ -27969,13 +28597,12 @@
               <a:srgbClr val="0F4C6B"/>
             </a:solidFill>
             <a:prstDash val="solid"/>
-            <a:tailEnd type="triangle"/>
           </a:ln>
         </p:spPr>
       </p:sp>
       <p:sp>
         <p:nvSpPr>
-          <p:cNvPr id="30" name="Shape 25"/>
+          <p:cNvPr id="33" name="Shape 28"/>
           <p:cNvSpPr/>
           <p:nvPr/>
         </p:nvSpPr>
@@ -28002,7 +28629,7 @@
       </p:sp>
       <p:pic>
         <p:nvPicPr>
-          <p:cNvPr id="31" name="Image 3" descr="preencoded.png">    </p:cNvPr>
+          <p:cNvPr id="34" name="Image 3" descr="preencoded.png">    </p:cNvPr>
           <p:cNvPicPr>
             <a:picLocks noChangeAspect="1"/>
           </p:cNvPicPr>
@@ -28026,7 +28653,7 @@
       </p:pic>
       <p:sp>
         <p:nvSpPr>
-          <p:cNvPr id="32" name="Text 26"/>
+          <p:cNvPr id="35" name="Text 29"/>
           <p:cNvSpPr txBox="1"/>
           <p:nvPr/>
         </p:nvSpPr>
@@ -28065,7 +28692,7 @@
       </p:sp>
       <p:sp>
         <p:nvSpPr>
-          <p:cNvPr id="33" name="Text 27"/>
+          <p:cNvPr id="36" name="Text 30"/>
           <p:cNvSpPr txBox="1"/>
           <p:nvPr/>
         </p:nvSpPr>
@@ -28104,7 +28731,7 @@
       </p:sp>
       <p:sp>
         <p:nvSpPr>
-          <p:cNvPr id="34" name="Shape 28"/>
+          <p:cNvPr id="37" name="Shape 31"/>
           <p:cNvSpPr/>
           <p:nvPr/>
         </p:nvSpPr>
@@ -28127,7 +28754,7 @@
       </p:sp>
       <p:sp>
         <p:nvSpPr>
-          <p:cNvPr id="35" name="Shape 29"/>
+          <p:cNvPr id="38" name="Shape 32"/>
           <p:cNvSpPr/>
           <p:nvPr/>
         </p:nvSpPr>
@@ -28150,14 +28777,34 @@
       </p:sp>
       <p:sp>
         <p:nvSpPr>
-          <p:cNvPr id="36" name="Shape 30"/>
+          <p:cNvPr id="39" name="Shape 33"/>
+          <p:cNvSpPr/>
+          <p:nvPr/>
+        </p:nvSpPr>
+        <p:spPr>
+          <a:xfrm>
+            <a:off x="1802511" y="5349240"/>
+            <a:ext cx="125730" cy="125730"/>
+          </a:xfrm>
+          <a:prstGeom prst="triangle">
+            <a:avLst/>
+          </a:prstGeom>
+          <a:solidFill>
+            <a:srgbClr val="0E7C86"/>
+          </a:solidFill>
+          <a:ln/>
+        </p:spPr>
+      </p:sp>
+      <p:sp>
+        <p:nvSpPr>
+          <p:cNvPr id="40" name="Shape 34"/>
           <p:cNvSpPr/>
           <p:nvPr/>
         </p:nvSpPr>
         <p:spPr>
           <a:xfrm flipV="1">
-            <a:off x="1865376" y="5349240"/>
-            <a:ext cx="0" cy="411480"/>
+            <a:off x="1865376" y="5412105"/>
+            <a:ext cx="0" cy="348615"/>
           </a:xfrm>
           <a:prstGeom prst="line">
             <a:avLst/>
@@ -28168,13 +28815,12 @@
               <a:srgbClr val="0E7C86"/>
             </a:solidFill>
             <a:prstDash val="solid"/>
-            <a:tailEnd type="triangle"/>
           </a:ln>
         </p:spPr>
       </p:sp>
       <p:sp>
         <p:nvSpPr>
-          <p:cNvPr id="37" name="Text 31"/>
+          <p:cNvPr id="41" name="Text 35"/>
           <p:cNvSpPr txBox="1"/>
           <p:nvPr/>
         </p:nvSpPr>
@@ -28215,7 +28861,7 @@
       </p:sp>
       <p:sp>
         <p:nvSpPr>
-          <p:cNvPr id="38" name="Text 32"/>
+          <p:cNvPr id="42" name="Text 36"/>
           <p:cNvSpPr txBox="1"/>
           <p:nvPr/>
         </p:nvSpPr>
@@ -28254,7 +28900,7 @@
       </p:sp>
       <p:sp>
         <p:nvSpPr>
-          <p:cNvPr id="39" name="Text 33"/>
+          <p:cNvPr id="43" name="Text 37"/>
           <p:cNvSpPr txBox="1"/>
           <p:nvPr/>
         </p:nvSpPr>
@@ -46384,9 +47030,29 @@
           <p:nvPr/>
         </p:nvSpPr>
         <p:spPr>
+          <a:xfrm rot="5400000">
+            <a:off x="3886200" y="3223260"/>
+            <a:ext cx="137160" cy="137160"/>
+          </a:xfrm>
+          <a:prstGeom prst="triangle">
+            <a:avLst/>
+          </a:prstGeom>
+          <a:solidFill>
+            <a:srgbClr val="0F4C6B"/>
+          </a:solidFill>
+          <a:ln/>
+        </p:spPr>
+      </p:sp>
+      <p:sp>
+        <p:nvSpPr>
+          <p:cNvPr id="37" name="Shape 27"/>
+          <p:cNvSpPr/>
+          <p:nvPr/>
+        </p:nvSpPr>
+        <p:spPr>
           <a:xfrm>
             <a:off x="3429000" y="3291840"/>
-            <a:ext cx="594360" cy="0"/>
+            <a:ext cx="525780" cy="0"/>
           </a:xfrm>
           <a:prstGeom prst="line">
             <a:avLst/>
@@ -46397,13 +47063,12 @@
               <a:srgbClr val="0F4C6B"/>
             </a:solidFill>
             <a:prstDash val="solid"/>
-            <a:tailEnd type="triangle"/>
           </a:ln>
         </p:spPr>
       </p:sp>
       <p:sp>
         <p:nvSpPr>
-          <p:cNvPr id="37" name="Text 27"/>
+          <p:cNvPr id="38" name="Text 28"/>
           <p:cNvSpPr txBox="1"/>
           <p:nvPr/>
         </p:nvSpPr>
@@ -46442,14 +47107,34 @@
       </p:sp>
       <p:sp>
         <p:nvSpPr>
-          <p:cNvPr id="38" name="Shape 28"/>
+          <p:cNvPr id="39" name="Shape 29"/>
+          <p:cNvSpPr/>
+          <p:nvPr/>
+        </p:nvSpPr>
+        <p:spPr>
+          <a:xfrm rot="5400000">
+            <a:off x="8641080" y="3223260"/>
+            <a:ext cx="137160" cy="137160"/>
+          </a:xfrm>
+          <a:prstGeom prst="triangle">
+            <a:avLst/>
+          </a:prstGeom>
+          <a:solidFill>
+            <a:srgbClr val="0F4C6B"/>
+          </a:solidFill>
+          <a:ln/>
+        </p:spPr>
+      </p:sp>
+      <p:sp>
+        <p:nvSpPr>
+          <p:cNvPr id="40" name="Shape 30"/>
           <p:cNvSpPr/>
           <p:nvPr/>
         </p:nvSpPr>
         <p:spPr>
           <a:xfrm>
             <a:off x="8183880" y="3291840"/>
-            <a:ext cx="594360" cy="0"/>
+            <a:ext cx="525780" cy="0"/>
           </a:xfrm>
           <a:prstGeom prst="line">
             <a:avLst/>
@@ -46460,13 +47145,12 @@
               <a:srgbClr val="0F4C6B"/>
             </a:solidFill>
             <a:prstDash val="solid"/>
-            <a:tailEnd type="triangle"/>
           </a:ln>
         </p:spPr>
       </p:sp>
       <p:sp>
         <p:nvSpPr>
-          <p:cNvPr id="39" name="Text 29"/>
+          <p:cNvPr id="41" name="Text 31"/>
           <p:cNvSpPr txBox="1"/>
           <p:nvPr/>
         </p:nvSpPr>
@@ -46505,7 +47189,7 @@
       </p:sp>
       <p:sp>
         <p:nvSpPr>
-          <p:cNvPr id="40" name="Shape 30"/>
+          <p:cNvPr id="42" name="Shape 32"/>
           <p:cNvSpPr/>
           <p:nvPr/>
         </p:nvSpPr>
@@ -46527,7 +47211,7 @@
       </p:sp>
       <p:pic>
         <p:nvPicPr>
-          <p:cNvPr id="41" name="Image 8" descr="preencoded.png">    </p:cNvPr>
+          <p:cNvPr id="43" name="Image 8" descr="preencoded.png">    </p:cNvPr>
           <p:cNvPicPr>
             <a:picLocks noChangeAspect="1"/>
           </p:cNvPicPr>
@@ -46551,7 +47235,7 @@
       </p:pic>
       <p:sp>
         <p:nvSpPr>
-          <p:cNvPr id="42" name="Text 31"/>
+          <p:cNvPr id="44" name="Text 33"/>
           <p:cNvSpPr txBox="1"/>
           <p:nvPr/>
         </p:nvSpPr>
@@ -46590,14 +47274,34 @@
       </p:sp>
       <p:sp>
         <p:nvSpPr>
-          <p:cNvPr id="43" name="Shape 32"/>
+          <p:cNvPr id="45" name="Shape 34"/>
+          <p:cNvSpPr/>
+          <p:nvPr/>
+        </p:nvSpPr>
+        <p:spPr>
+          <a:xfrm>
+            <a:off x="6030468" y="4617720"/>
+            <a:ext cx="137160" cy="137160"/>
+          </a:xfrm>
+          <a:prstGeom prst="triangle">
+            <a:avLst/>
+          </a:prstGeom>
+          <a:solidFill>
+            <a:srgbClr val="0E7C86"/>
+          </a:solidFill>
+          <a:ln/>
+        </p:spPr>
+      </p:sp>
+      <p:sp>
+        <p:nvSpPr>
+          <p:cNvPr id="46" name="Shape 35"/>
           <p:cNvSpPr/>
           <p:nvPr/>
         </p:nvSpPr>
         <p:spPr>
           <a:xfrm flipV="1">
-            <a:off x="6099048" y="4617720"/>
-            <a:ext cx="0" cy="256032"/>
+            <a:off x="6099048" y="4686300"/>
+            <a:ext cx="0" cy="187452"/>
           </a:xfrm>
           <a:prstGeom prst="line">
             <a:avLst/>
@@ -46608,13 +47312,12 @@
               <a:srgbClr val="0E7C86"/>
             </a:solidFill>
             <a:prstDash val="solid"/>
-            <a:tailEnd type="triangle"/>
           </a:ln>
         </p:spPr>
       </p:sp>
       <p:sp>
         <p:nvSpPr>
-          <p:cNvPr id="44" name="Shape 33"/>
+          <p:cNvPr id="47" name="Shape 36"/>
           <p:cNvSpPr/>
           <p:nvPr/>
         </p:nvSpPr>
@@ -46634,7 +47337,7 @@
       </p:sp>
       <p:pic>
         <p:nvPicPr>
-          <p:cNvPr id="45" name="Image 9" descr="preencoded.png">    </p:cNvPr>
+          <p:cNvPr id="48" name="Image 9" descr="preencoded.png">    </p:cNvPr>
           <p:cNvPicPr>
             <a:picLocks noChangeAspect="1"/>
           </p:cNvPicPr>
@@ -46658,7 +47361,7 @@
       </p:pic>
       <p:sp>
         <p:nvSpPr>
-          <p:cNvPr id="46" name="Text 34"/>
+          <p:cNvPr id="49" name="Text 37"/>
           <p:cNvSpPr txBox="1"/>
           <p:nvPr/>
         </p:nvSpPr>
@@ -46697,7 +47400,7 @@
       </p:sp>
       <p:sp>
         <p:nvSpPr>
-          <p:cNvPr id="47" name="Shape 35"/>
+          <p:cNvPr id="50" name="Shape 38"/>
           <p:cNvSpPr/>
           <p:nvPr/>
         </p:nvSpPr>
@@ -46717,7 +47420,7 @@
       </p:sp>
       <p:pic>
         <p:nvPicPr>
-          <p:cNvPr id="48" name="Image 10" descr="preencoded.png">    </p:cNvPr>
+          <p:cNvPr id="51" name="Image 10" descr="preencoded.png">    </p:cNvPr>
           <p:cNvPicPr>
             <a:picLocks noChangeAspect="1"/>
           </p:cNvPicPr>
@@ -46741,7 +47444,7 @@
       </p:pic>
       <p:sp>
         <p:nvSpPr>
-          <p:cNvPr id="49" name="Text 36"/>
+          <p:cNvPr id="52" name="Text 39"/>
           <p:cNvSpPr txBox="1"/>
           <p:nvPr/>
         </p:nvSpPr>
@@ -46780,7 +47483,7 @@
       </p:sp>
       <p:sp>
         <p:nvSpPr>
-          <p:cNvPr id="50" name="Shape 37"/>
+          <p:cNvPr id="53" name="Shape 40"/>
           <p:cNvSpPr/>
           <p:nvPr/>
         </p:nvSpPr>
@@ -46800,7 +47503,7 @@
       </p:sp>
       <p:pic>
         <p:nvPicPr>
-          <p:cNvPr id="51" name="Image 11" descr="preencoded.png">    </p:cNvPr>
+          <p:cNvPr id="54" name="Image 11" descr="preencoded.png">    </p:cNvPr>
           <p:cNvPicPr>
             <a:picLocks noChangeAspect="1"/>
           </p:cNvPicPr>
@@ -46824,7 +47527,7 @@
       </p:pic>
       <p:sp>
         <p:nvSpPr>
-          <p:cNvPr id="52" name="Text 38"/>
+          <p:cNvPr id="55" name="Text 41"/>
           <p:cNvSpPr txBox="1"/>
           <p:nvPr/>
         </p:nvSpPr>
@@ -46863,7 +47566,7 @@
       </p:sp>
       <p:sp>
         <p:nvSpPr>
-          <p:cNvPr id="53" name="Text 39"/>
+          <p:cNvPr id="56" name="Text 42"/>
           <p:cNvSpPr txBox="1"/>
           <p:nvPr/>
         </p:nvSpPr>
@@ -46902,7 +47605,7 @@
       </p:sp>
       <p:sp>
         <p:nvSpPr>
-          <p:cNvPr id="54" name="Text 40"/>
+          <p:cNvPr id="57" name="Text 43"/>
           <p:cNvSpPr txBox="1"/>
           <p:nvPr/>
         </p:nvSpPr>

</xml_diff>